<commit_message>
chore: publish pending workspace asset
</commit_message>
<xml_diff>
--- a/documentation/pepite/oral-jury-6'-SNEE.pptx
+++ b/documentation/pepite/oral-jury-6'-SNEE.pptx
@@ -5,17 +5,17 @@
     <p:sldMasterId id="2147483648" r:id="rId1"/>
   </p:sldMasterIdLst>
   <p:notesMasterIdLst>
-    <p:notesMasterId r:id="rId17"/>
+    <p:notesMasterId r:id="rId10"/>
   </p:notesMasterIdLst>
   <p:sldIdLst>
-    <p:sldId id="276" r:id="rId3"/>
-    <p:sldId id="258" r:id="rId4"/>
-    <p:sldId id="260" r:id="rId5"/>
-    <p:sldId id="261" r:id="rId6"/>
-    <p:sldId id="262" r:id="rId7"/>
-    <p:sldId id="264" r:id="rId9"/>
-    <p:sldId id="272" r:id="rId14"/>
-    <p:sldId id="275" r:id="rId15"/>
+    <p:sldId id="276" r:id="rId2"/>
+    <p:sldId id="258" r:id="rId3"/>
+    <p:sldId id="260" r:id="rId4"/>
+    <p:sldId id="261" r:id="rId5"/>
+    <p:sldId id="262" r:id="rId6"/>
+    <p:sldId id="264" r:id="rId7"/>
+    <p:sldId id="272" r:id="rId8"/>
+    <p:sldId id="275" r:id="rId9"/>
   </p:sldIdLst>
   <p:sldSz cx="12192000" cy="6858000"/>
   <p:notesSz cx="6858000" cy="12192000"/>
@@ -111,12 +111,15 @@
       </a:defRPr>
     </a:lvl9pPr>
   </p:defaultTextStyle>
-  <p:extLst>
-    <p:ext uri="{EFAFB233-063F-42B5-8137-9DF3F51BA10A}">
-      <p15:sldGuideLst xmlns:p15="http://schemas.microsoft.com/office/powerpoint/2012/main"/>
-    </p:ext>
-  </p:extLst>
 </p:presentation>
+</file>
+
+<file path=ppt/revisionInfo.xml><?xml version="1.0" encoding="utf-8"?>
+<p1510:revInfo xmlns:a="http://schemas.openxmlformats.org/drawingml/2006/main" xmlns:r="http://schemas.openxmlformats.org/officeDocument/2006/relationships" xmlns:p1510="http://schemas.microsoft.com/office/powerpoint/2015/10/main">
+  <p1510:revLst>
+    <p1510:client id="{9BED5EB1-49DB-41DC-8BEE-BE4496FFD084}" v="208" dt="2026-08-08T16:25:55.692"/>
+  </p1510:revLst>
+</p1510:revInfo>
 </file>
 
 <file path=ppt/notesMasters/notesMaster1.xml><?xml version="1.0" encoding="utf-8"?>
@@ -244,7 +247,7 @@
 </p:notesMaster>
 </file>
 
-<file path=ppt/notesSlides/notesSlide13.xml><?xml version="1.0" encoding="utf-8"?>
+<file path=ppt/notesSlides/notesSlide1.xml><?xml version="1.0" encoding="utf-8"?>
 <p:notes xmlns:a="http://schemas.openxmlformats.org/drawingml/2006/main" xmlns:r="http://schemas.openxmlformats.org/officeDocument/2006/relationships" xmlns:p="http://schemas.openxmlformats.org/presentationml/2006/main">
   <p:cSld>
     <p:spTree>
@@ -288,7 +291,7 @@
           <a:bodyPr/>
           <a:lstStyle/>
           <a:p>
-            <a:endParaRPr lang="en-US" dirty="0"/>
+            <a:endParaRPr lang="en-US"/>
           </a:p>
         </p:txBody>
       </p:sp>
@@ -309,7 +312,7 @@
           <a:p>
             <a:fld id="{F7021451-1387-4CA6-816F-3879F97B5CBC}" type="slidenum">
               <a:rPr lang="en-US"/>
-              <a:t>13</a:t>
+              <a:t>1</a:t>
             </a:fld>
             <a:endParaRPr lang="en-US"/>
           </a:p>
@@ -318,91 +321,7 @@
     </p:spTree>
     <p:extLst>
       <p:ext uri="{BB962C8B-B14F-4D97-AF65-F5344CB8AC3E}">
-        <p14:creationId xmlns:p14="http://schemas.microsoft.com/office/powerpoint/2010/main" val="1024086991"/>
-      </p:ext>
-    </p:extLst>
-  </p:cSld>
-  <p:clrMapOvr>
-    <a:masterClrMapping/>
-  </p:clrMapOvr>
-</p:notes>
-</file>
-
-<file path=ppt/notesSlides/notesSlide14.xml><?xml version="1.0" encoding="utf-8"?>
-<p:notes xmlns:a="http://schemas.openxmlformats.org/drawingml/2006/main" xmlns:r="http://schemas.openxmlformats.org/officeDocument/2006/relationships" xmlns:p="http://schemas.openxmlformats.org/presentationml/2006/main">
-  <p:cSld>
-    <p:spTree>
-      <p:nvGrpSpPr>
-        <p:cNvPr id="1" name=""/>
-        <p:cNvGrpSpPr/>
-        <p:nvPr/>
-      </p:nvGrpSpPr>
-      <p:grpSpPr>
-        <a:xfrm>
-          <a:off x="0" y="0"/>
-          <a:ext cx="0" cy="0"/>
-          <a:chOff x="0" y="0"/>
-          <a:chExt cx="0" cy="0"/>
-        </a:xfrm>
-      </p:grpSpPr>
-      <p:sp>
-        <p:nvSpPr>
-          <p:cNvPr id="2" name="Slide Image Placeholder 1"/>
-          <p:cNvSpPr>
-            <a:spLocks noGrp="1" noRot="1" noChangeAspect="1"/>
-          </p:cNvSpPr>
-          <p:nvPr>
-            <p:ph type="sldImg"/>
-          </p:nvPr>
-        </p:nvSpPr>
-        <p:spPr/>
-      </p:sp>
-      <p:sp>
-        <p:nvSpPr>
-          <p:cNvPr id="3" name="Notes Placeholder 2"/>
-          <p:cNvSpPr>
-            <a:spLocks noGrp="1"/>
-          </p:cNvSpPr>
-          <p:nvPr>
-            <p:ph type="body" idx="1"/>
-          </p:nvPr>
-        </p:nvSpPr>
-        <p:spPr/>
-        <p:txBody>
-          <a:bodyPr/>
-          <a:lstStyle/>
-          <a:p>
-            <a:endParaRPr lang="en-US" dirty="0"/>
-          </a:p>
-        </p:txBody>
-      </p:sp>
-      <p:sp>
-        <p:nvSpPr>
-          <p:cNvPr id="4" name="Slide Number Placeholder 3"/>
-          <p:cNvSpPr>
-            <a:spLocks noGrp="1"/>
-          </p:cNvSpPr>
-          <p:nvPr>
-            <p:ph type="sldNum" sz="quarter" idx="10"/>
-          </p:nvPr>
-        </p:nvSpPr>
-        <p:spPr/>
-        <p:txBody>
-          <a:bodyPr/>
-          <a:lstStyle/>
-          <a:p>
-            <a:fld id="{F7021451-1387-4CA6-816F-3879F97B5CBC}" type="slidenum">
-              <a:rPr lang="en-US"/>
-              <a:t>14</a:t>
-            </a:fld>
-            <a:endParaRPr lang="en-US"/>
-          </a:p>
-        </p:txBody>
-      </p:sp>
-    </p:spTree>
-    <p:extLst>
-      <p:ext uri="{BB962C8B-B14F-4D97-AF65-F5344CB8AC3E}">
-        <p14:creationId xmlns:p14="http://schemas.microsoft.com/office/powerpoint/2010/main" val="1325434563"/>
+        <p14:creationId xmlns:p14="http://schemas.microsoft.com/office/powerpoint/2010/main" val="428726795"/>
       </p:ext>
     </p:extLst>
   </p:cSld>
@@ -456,7 +375,7 @@
           <a:bodyPr/>
           <a:lstStyle/>
           <a:p>
-            <a:endParaRPr lang="en-US" dirty="0"/>
+            <a:endParaRPr lang="en-US"/>
           </a:p>
         </p:txBody>
       </p:sp>
@@ -486,7 +405,7 @@
     </p:spTree>
     <p:extLst>
       <p:ext uri="{BB962C8B-B14F-4D97-AF65-F5344CB8AC3E}">
-        <p14:creationId xmlns:p14="http://schemas.microsoft.com/office/powerpoint/2010/main" val="428726795"/>
+        <p14:creationId xmlns:p14="http://schemas.microsoft.com/office/powerpoint/2010/main" val="1024086991"/>
       </p:ext>
     </p:extLst>
   </p:cSld>
@@ -540,7 +459,7 @@
           <a:bodyPr/>
           <a:lstStyle/>
           <a:p>
-            <a:endParaRPr lang="en-US" dirty="0"/>
+            <a:endParaRPr lang="en-US"/>
           </a:p>
         </p:txBody>
       </p:sp>
@@ -624,7 +543,7 @@
           <a:bodyPr/>
           <a:lstStyle/>
           <a:p>
-            <a:endParaRPr lang="en-US" dirty="0"/>
+            <a:endParaRPr lang="en-US"/>
           </a:p>
         </p:txBody>
       </p:sp>
@@ -708,7 +627,7 @@
           <a:bodyPr/>
           <a:lstStyle/>
           <a:p>
-            <a:endParaRPr lang="en-US" dirty="0"/>
+            <a:endParaRPr lang="en-US"/>
           </a:p>
         </p:txBody>
       </p:sp>
@@ -792,7 +711,7 @@
           <a:bodyPr/>
           <a:lstStyle/>
           <a:p>
-            <a:endParaRPr lang="en-US" dirty="0"/>
+            <a:endParaRPr lang="en-US"/>
           </a:p>
         </p:txBody>
       </p:sp>
@@ -814,6 +733,90 @@
             <a:fld id="{F7021451-1387-4CA6-816F-3879F97B5CBC}" type="slidenum">
               <a:rPr lang="en-US"/>
               <a:t>6</a:t>
+            </a:fld>
+            <a:endParaRPr lang="en-US"/>
+          </a:p>
+        </p:txBody>
+      </p:sp>
+    </p:spTree>
+    <p:extLst>
+      <p:ext uri="{BB962C8B-B14F-4D97-AF65-F5344CB8AC3E}">
+        <p14:creationId xmlns:p14="http://schemas.microsoft.com/office/powerpoint/2010/main" val="1024086991"/>
+      </p:ext>
+    </p:extLst>
+  </p:cSld>
+  <p:clrMapOvr>
+    <a:masterClrMapping/>
+  </p:clrMapOvr>
+</p:notes>
+</file>
+
+<file path=ppt/notesSlides/notesSlide7.xml><?xml version="1.0" encoding="utf-8"?>
+<p:notes xmlns:a="http://schemas.openxmlformats.org/drawingml/2006/main" xmlns:r="http://schemas.openxmlformats.org/officeDocument/2006/relationships" xmlns:p="http://schemas.openxmlformats.org/presentationml/2006/main">
+  <p:cSld>
+    <p:spTree>
+      <p:nvGrpSpPr>
+        <p:cNvPr id="1" name=""/>
+        <p:cNvGrpSpPr/>
+        <p:nvPr/>
+      </p:nvGrpSpPr>
+      <p:grpSpPr>
+        <a:xfrm>
+          <a:off x="0" y="0"/>
+          <a:ext cx="0" cy="0"/>
+          <a:chOff x="0" y="0"/>
+          <a:chExt cx="0" cy="0"/>
+        </a:xfrm>
+      </p:grpSpPr>
+      <p:sp>
+        <p:nvSpPr>
+          <p:cNvPr id="2" name="Slide Image Placeholder 1"/>
+          <p:cNvSpPr>
+            <a:spLocks noGrp="1" noRot="1" noChangeAspect="1"/>
+          </p:cNvSpPr>
+          <p:nvPr>
+            <p:ph type="sldImg"/>
+          </p:nvPr>
+        </p:nvSpPr>
+        <p:spPr/>
+      </p:sp>
+      <p:sp>
+        <p:nvSpPr>
+          <p:cNvPr id="3" name="Notes Placeholder 2"/>
+          <p:cNvSpPr>
+            <a:spLocks noGrp="1"/>
+          </p:cNvSpPr>
+          <p:nvPr>
+            <p:ph type="body" idx="1"/>
+          </p:nvPr>
+        </p:nvSpPr>
+        <p:spPr/>
+        <p:txBody>
+          <a:bodyPr/>
+          <a:lstStyle/>
+          <a:p>
+            <a:endParaRPr lang="en-US"/>
+          </a:p>
+        </p:txBody>
+      </p:sp>
+      <p:sp>
+        <p:nvSpPr>
+          <p:cNvPr id="4" name="Slide Number Placeholder 3"/>
+          <p:cNvSpPr>
+            <a:spLocks noGrp="1"/>
+          </p:cNvSpPr>
+          <p:nvPr>
+            <p:ph type="sldNum" sz="quarter" idx="10"/>
+          </p:nvPr>
+        </p:nvSpPr>
+        <p:spPr/>
+        <p:txBody>
+          <a:bodyPr/>
+          <a:lstStyle/>
+          <a:p>
+            <a:fld id="{F7021451-1387-4CA6-816F-3879F97B5CBC}" type="slidenum">
+              <a:rPr lang="en-US"/>
+              <a:t>7</a:t>
             </a:fld>
             <a:endParaRPr lang="en-US"/>
           </a:p>
@@ -876,7 +879,7 @@
           <a:bodyPr/>
           <a:lstStyle/>
           <a:p>
-            <a:endParaRPr lang="en-US" dirty="0"/>
+            <a:endParaRPr lang="en-US"/>
           </a:p>
         </p:txBody>
       </p:sp>
@@ -906,7 +909,7 @@
     </p:spTree>
     <p:extLst>
       <p:ext uri="{BB962C8B-B14F-4D97-AF65-F5344CB8AC3E}">
-        <p14:creationId xmlns:p14="http://schemas.microsoft.com/office/powerpoint/2010/main" val="1024086991"/>
+        <p14:creationId xmlns:p14="http://schemas.microsoft.com/office/powerpoint/2010/main" val="1325434563"/>
       </p:ext>
     </p:extLst>
   </p:cSld>
@@ -1280,15 +1283,18 @@
               <a:buNone/>
             </a:pPr>
             <a:r>
-              <a:rPr sz="1300" b="1">
+              <a:rPr sz="1600" b="1">
                 <a:solidFill>
                   <a:srgbClr val="10B981"/>
                 </a:solidFill>
                 <a:latin typeface="Calibri"/>
               </a:rPr>
-              <a:t>DOSSIER DE CANDIDATURE — SNEE/D2E</a:t>
-            </a:r>
-            <a:endParaRPr lang="en-US" sz="1300" dirty="0"/>
+              <a:t>DOSSIER DE CANDIDATURE — SNEE</a:t>
+            </a:r>
+            <a:endParaRPr lang="en-US" sz="1600">
+              <a:ea typeface="Calibri"/>
+              <a:cs typeface="Calibri"/>
+            </a:endParaRPr>
           </a:p>
         </p:txBody>
       </p:sp>
@@ -1300,8 +1306,8 @@
         </p:nvSpPr>
         <p:spPr>
           <a:xfrm>
-            <a:off x="594360" y="1097280"/>
-            <a:ext cx="6400800" cy="1280160"/>
+            <a:off x="616131" y="1053738"/>
+            <a:ext cx="7726371" cy="1365455"/>
           </a:xfrm>
           <a:prstGeom prst="rect">
             <a:avLst/>
@@ -1319,14 +1325,14 @@
               <a:buNone/>
             </a:pPr>
             <a:r>
-              <a:rPr sz="6000" b="1">
+              <a:rPr sz="6600" b="1">
                 <a:solidFill>
                   <a:srgbClr val="064E3B"/>
                 </a:solidFill>
               </a:rPr>
               <a:t>CleanMyMap</a:t>
             </a:r>
-            <a:endParaRPr lang="en-US" sz="6000" dirty="0"/>
+            <a:endParaRPr lang="en-US" sz="6600"/>
           </a:p>
         </p:txBody>
       </p:sp>
@@ -1338,8 +1344,8 @@
         </p:nvSpPr>
         <p:spPr>
           <a:xfrm>
-            <a:off x="640080" y="2377440"/>
-            <a:ext cx="6035040" cy="548640"/>
+            <a:off x="619204" y="2377440"/>
+            <a:ext cx="9083039" cy="559078"/>
           </a:xfrm>
           <a:prstGeom prst="rect">
             <a:avLst/>
@@ -1353,19 +1359,130 @@
           <a:bodyPr wrap="square" lIns="0" tIns="0" rIns="0" bIns="0" rtlCol="0" anchor="ctr"/>
           <a:lstStyle/>
           <a:p>
-            <a:pPr marL="0" indent="0">
-              <a:buNone/>
-            </a:pPr>
-            <a:r>
-              <a:rPr i="1">
-                <a:solidFill>
-                  <a:srgbClr val="475569"/>
-                </a:solidFill>
-                <a:latin typeface="Calibri"/>
-              </a:rPr>
-              <a:t>Cartographier, déclarer et valoriser les actions locales de dépollution.</a:t>
-            </a:r>
-            <a:endParaRPr lang="en-US" sz="1800" dirty="0"/>
+            <a:r>
+              <a:rPr sz="2000" i="1" err="1">
+                <a:solidFill>
+                  <a:srgbClr val="475569"/>
+                </a:solidFill>
+                <a:latin typeface="Calibri"/>
+              </a:rPr>
+              <a:t>Cartographier</a:t>
+            </a:r>
+            <a:r>
+              <a:rPr sz="2000" i="1">
+                <a:solidFill>
+                  <a:srgbClr val="475569"/>
+                </a:solidFill>
+                <a:latin typeface="Calibri"/>
+              </a:rPr>
+              <a:t>, </a:t>
+            </a:r>
+            <a:r>
+              <a:rPr lang="fr-FR" sz="2000" i="1" err="1">
+                <a:solidFill>
+                  <a:srgbClr val="475569"/>
+                </a:solidFill>
+                <a:latin typeface="Calibri"/>
+              </a:rPr>
+              <a:t>communiquer</a:t>
+            </a:r>
+            <a:r>
+              <a:rPr lang="fr-FR" sz="2000" i="1">
+                <a:solidFill>
+                  <a:srgbClr val="475569"/>
+                </a:solidFill>
+                <a:latin typeface="Calibri"/>
+              </a:rPr>
+              <a:t> </a:t>
+            </a:r>
+            <a:r>
+              <a:rPr sz="2000" i="1">
+                <a:solidFill>
+                  <a:srgbClr val="475569"/>
+                </a:solidFill>
+                <a:latin typeface="Calibri"/>
+              </a:rPr>
+              <a:t>et </a:t>
+            </a:r>
+            <a:r>
+              <a:rPr sz="2000" i="1" err="1">
+                <a:solidFill>
+                  <a:srgbClr val="475569"/>
+                </a:solidFill>
+                <a:latin typeface="Calibri"/>
+              </a:rPr>
+              <a:t>valoriser</a:t>
+            </a:r>
+            <a:r>
+              <a:rPr sz="2000" i="1">
+                <a:solidFill>
+                  <a:srgbClr val="475569"/>
+                </a:solidFill>
+                <a:latin typeface="Calibri"/>
+              </a:rPr>
+              <a:t> les actions </a:t>
+            </a:r>
+            <a:r>
+              <a:rPr lang="fr-FR" sz="2000" i="1">
+                <a:solidFill>
+                  <a:srgbClr val="475569"/>
+                </a:solidFill>
+                <a:latin typeface="Calibri"/>
+              </a:rPr>
+              <a:t>de</a:t>
+            </a:r>
+            <a:r>
+              <a:rPr sz="2000" i="1">
+                <a:solidFill>
+                  <a:srgbClr val="475569"/>
+                </a:solidFill>
+                <a:latin typeface="Calibri"/>
+              </a:rPr>
+              <a:t> </a:t>
+            </a:r>
+            <a:r>
+              <a:rPr lang="fr-FR" sz="2000" i="1" err="1">
+                <a:solidFill>
+                  <a:srgbClr val="475569"/>
+                </a:solidFill>
+                <a:latin typeface="Calibri"/>
+              </a:rPr>
+              <a:t>dépollutionde</a:t>
+            </a:r>
+            <a:r>
+              <a:rPr lang="fr-FR" sz="2000" i="1">
+                <a:solidFill>
+                  <a:srgbClr val="475569"/>
+                </a:solidFill>
+                <a:latin typeface="Calibri"/>
+              </a:rPr>
+              <a:t> </a:t>
+            </a:r>
+            <a:r>
+              <a:rPr lang="fr-FR" sz="2000" i="1" err="1">
+                <a:solidFill>
+                  <a:srgbClr val="475569"/>
+                </a:solidFill>
+                <a:latin typeface="Calibri"/>
+              </a:rPr>
+              <a:t>l'espace</a:t>
+            </a:r>
+            <a:r>
+              <a:rPr lang="fr-FR" sz="2000" i="1">
+                <a:solidFill>
+                  <a:srgbClr val="475569"/>
+                </a:solidFill>
+                <a:latin typeface="Calibri"/>
+              </a:rPr>
+              <a:t> public</a:t>
+            </a:r>
+            <a:endParaRPr lang="fr-FR" sz="2000" i="1">
+              <a:solidFill>
+                <a:srgbClr val="475569"/>
+              </a:solidFill>
+              <a:ea typeface="Calibri"/>
+              <a:cs typeface="Calibri"/>
+            </a:endParaRPr>
           </a:p>
         </p:txBody>
       </p:sp>
@@ -1377,8 +1494,8 @@
         </p:nvSpPr>
         <p:spPr>
           <a:xfrm>
-            <a:off x="640080" y="3200400"/>
-            <a:ext cx="5943600" cy="1737360"/>
+            <a:off x="619204" y="3200400"/>
+            <a:ext cx="8699324" cy="2008756"/>
           </a:xfrm>
           <a:prstGeom prst="roundRect">
             <a:avLst>
@@ -1394,7 +1511,10 @@
         </p:spPr>
         <p:txBody>
           <a:bodyPr/>
-          <a:p/>
+          <a:lstStyle/>
+          <a:p>
+            <a:endParaRPr sz="2000"/>
+          </a:p>
         </p:txBody>
       </p:sp>
       <p:sp>
@@ -1406,7 +1526,7 @@
         <p:spPr>
           <a:xfrm>
             <a:off x="914400" y="3429000"/>
-            <a:ext cx="5486400" cy="1508760"/>
+            <a:ext cx="8523960" cy="1560951"/>
           </a:xfrm>
           <a:prstGeom prst="rect">
             <a:avLst/>
@@ -1424,58 +1544,118 @@
               <a:buNone/>
             </a:pPr>
             <a:r>
-              <a:rPr sz="1800" b="1">
+              <a:rPr sz="2000" b="1">
                 <a:solidFill>
                   <a:srgbClr val="064E3B"/>
                 </a:solidFill>
                 <a:latin typeface="Calibri"/>
               </a:rPr>
-              <a:t>Maxence Deroome</a:t>
-            </a:r>
-            <a:endParaRPr lang="en-US" sz="1800" dirty="0"/>
-          </a:p>
-          <a:p>
-            <a:r>
-              <a:rPr sz="1800" b="1">
+              <a:t>Maxence </a:t>
+            </a:r>
+            <a:r>
+              <a:rPr sz="2000" b="1" err="1">
                 <a:solidFill>
                   <a:srgbClr val="064E3B"/>
                 </a:solidFill>
                 <a:latin typeface="Calibri"/>
               </a:rPr>
-              <a:t/>
-            </a:r>
-          </a:p>
-          <a:p>
-            <a:r>
-              <a:rPr sz="1800" b="1">
+              <a:t>Deroome</a:t>
+            </a:r>
+            <a:endParaRPr lang="en-US" sz="2000" err="1"/>
+          </a:p>
+          <a:p>
+            <a:endParaRPr lang="en-US" sz="2000"/>
+          </a:p>
+          <a:p>
+            <a:r>
+              <a:rPr sz="2000" b="1">
                 <a:solidFill>
                   <a:srgbClr val="064E3B"/>
                 </a:solidFill>
                 <a:latin typeface="Calibri"/>
               </a:rPr>
-              <a:t>Sorbonne Université — Licence Physique, mineure Environnement</a:t>
-            </a:r>
-          </a:p>
-          <a:p>
-            <a:r>
-              <a:rPr sz="1800" b="1">
+              <a:t>Sorbonne Université — </a:t>
+            </a:r>
+            <a:r>
+              <a:rPr sz="2000" b="1" err="1">
                 <a:solidFill>
                   <a:srgbClr val="064E3B"/>
                 </a:solidFill>
                 <a:latin typeface="Calibri"/>
               </a:rPr>
-              <a:t/>
-            </a:r>
-          </a:p>
-          <a:p>
-            <a:r>
-              <a:rPr sz="1800" b="1">
+              <a:t>Licence</a:t>
+            </a:r>
+            <a:r>
+              <a:rPr lang="fr-FR" sz="2000" b="1">
                 <a:solidFill>
                   <a:srgbClr val="064E3B"/>
                 </a:solidFill>
                 <a:latin typeface="Calibri"/>
               </a:rPr>
-              <a:t>Candidature SNEE/D2E 2026/2027</a:t>
+              <a:t> </a:t>
+            </a:r>
+            <a:r>
+              <a:rPr lang="fr-FR" sz="2000" b="1" err="1">
+                <a:solidFill>
+                  <a:srgbClr val="064E3B"/>
+                </a:solidFill>
+                <a:latin typeface="Calibri"/>
+              </a:rPr>
+              <a:t>Bidisciplinaire</a:t>
+            </a:r>
+            <a:r>
+              <a:rPr lang="fr-FR" sz="2000" b="1">
+                <a:solidFill>
+                  <a:srgbClr val="064E3B"/>
+                </a:solidFill>
+                <a:latin typeface="Calibri"/>
+              </a:rPr>
+              <a:t> : Physique &amp; Environnement</a:t>
+            </a:r>
+            <a:endParaRPr sz="2000" b="1">
+              <a:solidFill>
+                <a:srgbClr val="064E3B"/>
+              </a:solidFill>
+              <a:latin typeface="Calibri"/>
+              <a:ea typeface="Calibri"/>
+              <a:cs typeface="Calibri"/>
+            </a:endParaRPr>
+          </a:p>
+          <a:p>
+            <a:endParaRPr sz="2000" b="1">
+              <a:solidFill>
+                <a:srgbClr val="064E3B"/>
+              </a:solidFill>
+              <a:latin typeface="Calibri"/>
+            </a:endParaRPr>
+          </a:p>
+          <a:p>
+            <a:r>
+              <a:rPr sz="2000" b="1">
+                <a:solidFill>
+                  <a:srgbClr val="064E3B"/>
+                </a:solidFill>
+                <a:latin typeface="Calibri"/>
+              </a:rPr>
+              <a:t>Candidature </a:t>
+            </a:r>
+            <a:r>
+              <a:rPr lang="fr-FR" sz="2000" b="1">
+                <a:solidFill>
+                  <a:srgbClr val="064E3B"/>
+                </a:solidFill>
+                <a:latin typeface="Calibri"/>
+              </a:rPr>
+              <a:t>SNEE</a:t>
+            </a:r>
+            <a:r>
+              <a:rPr sz="2000" b="1">
+                <a:solidFill>
+                  <a:srgbClr val="064E3B"/>
+                </a:solidFill>
+                <a:latin typeface="Calibri"/>
+              </a:rPr>
+              <a:t> 2026/2027</a:t>
             </a:r>
           </a:p>
         </p:txBody>
@@ -1503,7 +1683,10 @@
         </p:spPr>
         <p:txBody>
           <a:bodyPr/>
-          <a:p/>
+          <a:lstStyle/>
+          <a:p>
+            <a:endParaRPr/>
+          </a:p>
         </p:txBody>
       </p:sp>
       <p:sp>
@@ -1533,15 +1716,36 @@
               <a:buNone/>
             </a:pPr>
             <a:r>
-              <a:rPr sz="1600" b="1">
+              <a:rPr b="1">
                 <a:solidFill>
                   <a:srgbClr val="FFFFFF"/>
                 </a:solidFill>
                 <a:latin typeface="Calibri"/>
               </a:rPr>
-              <a:t>Candidature SNEE/D2E — Pépite Sorbonne Université</a:t>
-            </a:r>
-            <a:endParaRPr lang="en-US" sz="1600" dirty="0"/>
+              <a:t>Candidature SNEE — </a:t>
+            </a:r>
+            <a:r>
+              <a:rPr b="1" err="1">
+                <a:solidFill>
+                  <a:srgbClr val="FFFFFF"/>
+                </a:solidFill>
+                <a:latin typeface="Calibri"/>
+              </a:rPr>
+              <a:t>Pépite</a:t>
+            </a:r>
+            <a:r>
+              <a:rPr b="1">
+                <a:solidFill>
+                  <a:srgbClr val="FFFFFF"/>
+                </a:solidFill>
+                <a:latin typeface="Calibri"/>
+              </a:rPr>
+              <a:t> Sorbonne Université</a:t>
+            </a:r>
+            <a:endParaRPr lang="en-US">
+              <a:ea typeface="Calibri"/>
+              <a:cs typeface="Calibri"/>
+            </a:endParaRPr>
           </a:p>
         </p:txBody>
       </p:sp>
@@ -1684,7 +1888,7 @@
               </a:rPr>
               <a:t>Présentation de l'équipe</a:t>
             </a:r>
-            <a:endParaRPr lang="en-US" sz="3200" dirty="0">
+            <a:endParaRPr lang="en-US" sz="3200">
               <a:latin typeface="Calibri" panose="020F0502020204030204" pitchFamily="34" charset="0"/>
               <a:cs typeface="Calibri" panose="020F0502020204030204" pitchFamily="34" charset="0"/>
             </a:endParaRPr>
@@ -1699,8 +1903,8 @@
         </p:nvSpPr>
         <p:spPr>
           <a:xfrm>
-            <a:off x="548640" y="1691640"/>
-            <a:ext cx="3383280" cy="4206240"/>
+            <a:off x="3387874" y="1294983"/>
+            <a:ext cx="5408320" cy="4206240"/>
           </a:xfrm>
           <a:prstGeom prst="roundRect">
             <a:avLst>
@@ -1716,552 +1920,9 @@
         </p:spPr>
         <p:txBody>
           <a:bodyPr/>
-          <a:p/>
-        </p:txBody>
-      </p:sp>
-      <p:sp>
-        <p:nvSpPr>
-          <p:cNvPr id="6" name="Shape 4"/>
-          <p:cNvSpPr/>
-          <p:nvPr/>
-        </p:nvSpPr>
-        <p:spPr>
-          <a:xfrm>
-            <a:off x="1554480" y="1965960"/>
-            <a:ext cx="1371600" cy="1371600"/>
-          </a:xfrm>
-          <a:prstGeom prst="ellipse">
-            <a:avLst/>
-          </a:prstGeom>
-          <a:solidFill>
-            <a:srgbClr val="D1FAE5"/>
-          </a:solidFill>
-          <a:ln>
-            <a:noFill/>
-          </a:ln>
-        </p:spPr>
-        <p:txBody>
-          <a:bodyPr/>
-          <a:p/>
-        </p:txBody>
-      </p:sp>
-      <p:sp>
-        <p:nvSpPr>
-          <p:cNvPr id="7" name="Text 5"/>
-          <p:cNvSpPr/>
-          <p:nvPr/>
-        </p:nvSpPr>
-        <p:spPr>
-          <a:xfrm>
-            <a:off x="1554480" y="1965960"/>
-            <a:ext cx="1371600" cy="1371600"/>
-          </a:xfrm>
-          <a:prstGeom prst="rect">
-            <a:avLst/>
-          </a:prstGeom>
-          <a:noFill/>
-          <a:ln>
-            <a:noFill/>
-          </a:ln>
-        </p:spPr>
-        <p:txBody>
-          <a:bodyPr wrap="square" lIns="0" tIns="0" rIns="0" bIns="0" rtlCol="0" anchor="ctr"/>
-          <a:lstStyle/>
-          <a:p>
-            <a:pPr marL="0" indent="0" algn="ctr">
-              <a:buNone/>
-            </a:pPr>
-            <a:r>
-              <a:rPr sz="1200" b="1">
-                <a:solidFill>
-                  <a:srgbClr val="064E3B"/>
-                </a:solidFill>
-                <a:latin typeface="Calibri"/>
-              </a:rPr>
-              <a:t>PHOTO</a:t>
-            </a:r>
-            <a:endParaRPr lang="en-US" sz="1200" dirty="0"/>
-          </a:p>
-        </p:txBody>
-      </p:sp>
-      <p:sp>
-        <p:nvSpPr>
-          <p:cNvPr id="8" name="Text 6"/>
-          <p:cNvSpPr/>
-          <p:nvPr/>
-        </p:nvSpPr>
-        <p:spPr>
-          <a:xfrm>
-            <a:off x="777240" y="3520440"/>
-            <a:ext cx="2926080" cy="365760"/>
-          </a:xfrm>
-          <a:prstGeom prst="rect">
-            <a:avLst/>
-          </a:prstGeom>
-          <a:noFill/>
-          <a:ln>
-            <a:noFill/>
-          </a:ln>
-        </p:spPr>
-        <p:txBody>
-          <a:bodyPr wrap="square" lIns="0" tIns="0" rIns="0" bIns="0" rtlCol="0" anchor="ctr"/>
-          <a:lstStyle/>
-          <a:p>
-            <a:pPr marL="0" indent="0" algn="ctr">
-              <a:buNone/>
-            </a:pPr>
-            <a:r>
-              <a:rPr sz="1600" b="1">
-                <a:solidFill>
-                  <a:srgbClr val="064E3B"/>
-                </a:solidFill>
-                <a:latin typeface="Calibri"/>
-              </a:rPr>
-              <a:t>Maxence Deroome</a:t>
-            </a:r>
-            <a:endParaRPr lang="en-US" sz="1600" dirty="0"/>
-          </a:p>
-        </p:txBody>
-      </p:sp>
-      <p:sp>
-        <p:nvSpPr>
-          <p:cNvPr id="9" name="Text 7"/>
-          <p:cNvSpPr/>
-          <p:nvPr/>
-        </p:nvSpPr>
-        <p:spPr>
-          <a:xfrm>
-            <a:off x="777240" y="3886200"/>
-            <a:ext cx="2926080" cy="320040"/>
-          </a:xfrm>
-          <a:prstGeom prst="rect">
-            <a:avLst/>
-          </a:prstGeom>
-          <a:noFill/>
-          <a:ln>
-            <a:noFill/>
-          </a:ln>
-        </p:spPr>
-        <p:txBody>
-          <a:bodyPr wrap="square" lIns="0" tIns="0" rIns="0" bIns="0" rtlCol="0" anchor="ctr"/>
-          <a:lstStyle/>
-          <a:p>
-            <a:pPr marL="0" indent="0" algn="ctr">
-              <a:buNone/>
-            </a:pPr>
-            <a:r>
-              <a:rPr sz="1300" i="1">
-                <a:solidFill>
-                  <a:srgbClr val="10B981"/>
-                </a:solidFill>
-                <a:latin typeface="Calibri"/>
-              </a:rPr>
-              <a:t>Porteur du projet</a:t>
-            </a:r>
-            <a:endParaRPr lang="en-US" sz="1300" dirty="0"/>
-          </a:p>
-        </p:txBody>
-      </p:sp>
-      <p:sp>
-        <p:nvSpPr>
-          <p:cNvPr id="10" name="Text 8"/>
-          <p:cNvSpPr/>
-          <p:nvPr/>
-        </p:nvSpPr>
-        <p:spPr>
-          <a:xfrm>
-            <a:off x="868680" y="4297680"/>
-            <a:ext cx="2743200" cy="1463040"/>
-          </a:xfrm>
-          <a:prstGeom prst="rect">
-            <a:avLst/>
-          </a:prstGeom>
-          <a:noFill/>
-          <a:ln>
-            <a:noFill/>
-          </a:ln>
-        </p:spPr>
-        <p:txBody>
-          <a:bodyPr wrap="square" lIns="0" tIns="0" rIns="0" bIns="0" rtlCol="0" anchor="ctr"/>
-          <a:lstStyle/>
-          <a:p>
-            <a:pPr marL="0" indent="0" algn="ctr">
-              <a:buNone/>
-            </a:pPr>
-            <a:r>
-              <a:rPr sz="1200">
-                <a:solidFill>
-                  <a:srgbClr val="475569"/>
-                </a:solidFill>
-                <a:latin typeface="Calibri"/>
-              </a:rPr>
-              <a:t>Étudiant à Sorbonne Université</a:t>
-            </a:r>
-            <a:endParaRPr lang="en-US" sz="1200" dirty="0"/>
-          </a:p>
-          <a:p>
-            <a:r>
-              <a:rPr sz="1200">
-                <a:solidFill>
-                  <a:srgbClr val="475569"/>
-                </a:solidFill>
-                <a:latin typeface="Calibri"/>
-              </a:rPr>
-              <a:t>Développement web, cartographie, données terrain</a:t>
-            </a:r>
-          </a:p>
-          <a:p>
-            <a:r>
-              <a:rPr sz="1200">
-                <a:solidFill>
-                  <a:srgbClr val="475569"/>
-                </a:solidFill>
-                <a:latin typeface="Calibri"/>
-              </a:rPr>
-              <a:t>Projet bénévole civic-tech</a:t>
-            </a:r>
-          </a:p>
-        </p:txBody>
-      </p:sp>
-      <p:sp>
-        <p:nvSpPr>
-          <p:cNvPr id="11" name="Shape 9"/>
-          <p:cNvSpPr/>
-          <p:nvPr/>
-        </p:nvSpPr>
-        <p:spPr>
-          <a:xfrm>
-            <a:off x="4206240" y="1691640"/>
-            <a:ext cx="3383280" cy="4206240"/>
-          </a:xfrm>
-          <a:prstGeom prst="roundRect">
-            <a:avLst>
-              <a:gd name="adj" fmla="val 2162"/>
-            </a:avLst>
-          </a:prstGeom>
-          <a:solidFill>
-            <a:srgbClr val="ECFDF5"/>
-          </a:solidFill>
-          <a:ln>
-            <a:noFill/>
-          </a:ln>
-        </p:spPr>
-        <p:txBody>
-          <a:bodyPr/>
-          <a:p/>
-        </p:txBody>
-      </p:sp>
-      <p:sp>
-        <p:nvSpPr>
-          <p:cNvPr id="12" name="Shape 10"/>
-          <p:cNvSpPr/>
-          <p:nvPr/>
-        </p:nvSpPr>
-        <p:spPr>
-          <a:xfrm>
-            <a:off x="5212080" y="1965960"/>
-            <a:ext cx="1371600" cy="1371600"/>
-          </a:xfrm>
-          <a:prstGeom prst="ellipse">
-            <a:avLst/>
-          </a:prstGeom>
-          <a:solidFill>
-            <a:srgbClr val="D1FAE5"/>
-          </a:solidFill>
-          <a:ln>
-            <a:noFill/>
-          </a:ln>
-        </p:spPr>
-        <p:txBody>
-          <a:bodyPr/>
-          <a:p/>
-        </p:txBody>
-      </p:sp>
-      <p:sp>
-        <p:nvSpPr>
-          <p:cNvPr id="13" name="Text 11"/>
-          <p:cNvSpPr/>
-          <p:nvPr/>
-        </p:nvSpPr>
-        <p:spPr>
-          <a:xfrm>
-            <a:off x="5212080" y="1965960"/>
-            <a:ext cx="1371600" cy="1371600"/>
-          </a:xfrm>
-          <a:prstGeom prst="rect">
-            <a:avLst/>
-          </a:prstGeom>
-          <a:noFill/>
-          <a:ln>
-            <a:noFill/>
-          </a:ln>
-        </p:spPr>
-        <p:txBody>
-          <a:bodyPr wrap="square" lIns="0" tIns="0" rIns="0" bIns="0" rtlCol="0" anchor="ctr"/>
-          <a:lstStyle/>
-          <a:p>
-            <a:pPr marL="0" indent="0" algn="ctr">
-              <a:buNone/>
-            </a:pPr>
-            <a:r>
-              <a:rPr sz="1200" b="1">
-                <a:solidFill>
-                  <a:srgbClr val="064E3B"/>
-                </a:solidFill>
-                <a:latin typeface="Calibri"/>
-              </a:rPr>
-              <a:t>RÉSEAU</a:t>
-            </a:r>
-            <a:endParaRPr lang="en-US" sz="1200" dirty="0"/>
-          </a:p>
-        </p:txBody>
-      </p:sp>
-      <p:sp>
-        <p:nvSpPr>
-          <p:cNvPr id="14" name="Text 12"/>
-          <p:cNvSpPr/>
-          <p:nvPr/>
-        </p:nvSpPr>
-        <p:spPr>
-          <a:xfrm>
-            <a:off x="4434840" y="3520440"/>
-            <a:ext cx="2926080" cy="365760"/>
-          </a:xfrm>
-          <a:prstGeom prst="rect">
-            <a:avLst/>
-          </a:prstGeom>
-          <a:noFill/>
-          <a:ln>
-            <a:noFill/>
-          </a:ln>
-        </p:spPr>
-        <p:txBody>
-          <a:bodyPr wrap="square" lIns="0" tIns="0" rIns="0" bIns="0" rtlCol="0" anchor="ctr"/>
-          <a:lstStyle/>
-          <a:p>
-            <a:pPr marL="0" indent="0" algn="ctr">
-              <a:buNone/>
-            </a:pPr>
-            <a:r>
-              <a:rPr sz="1600" b="1">
-                <a:solidFill>
-                  <a:srgbClr val="064E3B"/>
-                </a:solidFill>
-                <a:latin typeface="Calibri"/>
-              </a:rPr>
-              <a:t>Écosystème à consolider</a:t>
-            </a:r>
-            <a:endParaRPr lang="en-US" sz="1600" dirty="0"/>
-          </a:p>
-        </p:txBody>
-      </p:sp>
-      <p:sp>
-        <p:nvSpPr>
-          <p:cNvPr id="15" name="Text 13"/>
-          <p:cNvSpPr/>
-          <p:nvPr/>
-        </p:nvSpPr>
-        <p:spPr>
-          <a:xfrm>
-            <a:off x="4434840" y="3886200"/>
-            <a:ext cx="2926080" cy="320040"/>
-          </a:xfrm>
-          <a:prstGeom prst="rect">
-            <a:avLst/>
-          </a:prstGeom>
-          <a:noFill/>
-          <a:ln>
-            <a:noFill/>
-          </a:ln>
-        </p:spPr>
-        <p:txBody>
-          <a:bodyPr wrap="square" lIns="0" tIns="0" rIns="0" bIns="0" rtlCol="0" anchor="ctr"/>
-          <a:lstStyle/>
-          <a:p>
-            <a:pPr marL="0" indent="0" algn="ctr">
-              <a:buNone/>
-            </a:pPr>
-            <a:r>
-              <a:rPr sz="1300" i="1">
-                <a:solidFill>
-                  <a:srgbClr val="10B981"/>
-                </a:solidFill>
-                <a:latin typeface="Calibri"/>
-              </a:rPr>
-              <a:t>Associations · collectivités · acteurs terrain</a:t>
-            </a:r>
-            <a:endParaRPr lang="en-US" sz="1300" dirty="0"/>
-          </a:p>
-        </p:txBody>
-      </p:sp>
-      <p:sp>
-        <p:nvSpPr>
-          <p:cNvPr id="16" name="Text 14"/>
-          <p:cNvSpPr/>
-          <p:nvPr/>
-        </p:nvSpPr>
-        <p:spPr>
-          <a:xfrm>
-            <a:off x="4526280" y="4297680"/>
-            <a:ext cx="2743200" cy="1463040"/>
-          </a:xfrm>
-          <a:prstGeom prst="rect">
-            <a:avLst/>
-          </a:prstGeom>
-          <a:noFill/>
-          <a:ln>
-            <a:noFill/>
-          </a:ln>
-        </p:spPr>
-        <p:txBody>
-          <a:bodyPr wrap="square" lIns="0" tIns="0" rIns="0" bIns="0" rtlCol="0" anchor="ctr"/>
-          <a:lstStyle/>
-          <a:p>
-            <a:pPr marL="0" indent="0" algn="ctr">
-              <a:buNone/>
-            </a:pPr>
-            <a:r>
-              <a:rPr sz="1200">
-                <a:solidFill>
-                  <a:srgbClr val="475569"/>
-                </a:solidFill>
-                <a:latin typeface="Calibri"/>
-              </a:rPr>
-              <a:t>Contacts et pistes autour des cleanwalks, de la donnée terrain et de la sensibilisation</a:t>
-            </a:r>
-            <a:endParaRPr lang="en-US" sz="1200" dirty="0"/>
-          </a:p>
-        </p:txBody>
-      </p:sp>
-      <p:sp>
-        <p:nvSpPr>
-          <p:cNvPr id="17" name="Shape 15"/>
-          <p:cNvSpPr/>
-          <p:nvPr/>
-        </p:nvSpPr>
-        <p:spPr>
-          <a:xfrm>
-            <a:off x="8138160" y="1691640"/>
-            <a:ext cx="3474720" cy="4206240"/>
-          </a:xfrm>
-          <a:prstGeom prst="roundRect">
-            <a:avLst>
-              <a:gd name="adj" fmla="val 2105"/>
-            </a:avLst>
-          </a:prstGeom>
-          <a:solidFill>
-            <a:srgbClr val="ECFDF5"/>
-          </a:solidFill>
-          <a:ln>
-            <a:noFill/>
-          </a:ln>
-        </p:spPr>
-        <p:txBody>
-          <a:bodyPr/>
-          <a:p/>
-        </p:txBody>
-      </p:sp>
-      <p:sp>
-        <p:nvSpPr>
-          <p:cNvPr id="18" name="Text 16"/>
-          <p:cNvSpPr/>
-          <p:nvPr/>
-        </p:nvSpPr>
-        <p:spPr>
-          <a:xfrm>
-            <a:off x="8366760" y="1874520"/>
-            <a:ext cx="3017520" cy="411480"/>
-          </a:xfrm>
-          <a:prstGeom prst="rect">
-            <a:avLst/>
-          </a:prstGeom>
-          <a:noFill/>
-          <a:ln>
-            <a:noFill/>
-          </a:ln>
-        </p:spPr>
-        <p:txBody>
-          <a:bodyPr wrap="square" lIns="0" tIns="0" rIns="0" bIns="0" rtlCol="0" anchor="ctr"/>
-          <a:lstStyle/>
-          <a:p>
-            <a:pPr marL="0" indent="0">
-              <a:buNone/>
-            </a:pPr>
-            <a:r>
-              <a:rPr sz="1500" b="1">
-                <a:solidFill>
-                  <a:srgbClr val="10B981"/>
-                </a:solidFill>
-                <a:latin typeface="Calibri"/>
-              </a:rPr>
-              <a:t>Pourquoi la bonne équipe ?</a:t>
-            </a:r>
-            <a:endParaRPr lang="en-US" sz="1500" dirty="0"/>
-          </a:p>
-        </p:txBody>
-      </p:sp>
-      <p:sp>
-        <p:nvSpPr>
-          <p:cNvPr id="19" name="Text 17"/>
-          <p:cNvSpPr/>
-          <p:nvPr/>
-        </p:nvSpPr>
-        <p:spPr>
-          <a:xfrm>
-            <a:off x="8366760" y="2377440"/>
-            <a:ext cx="3017520" cy="3383280"/>
-          </a:xfrm>
-          <a:prstGeom prst="rect">
-            <a:avLst/>
-          </a:prstGeom>
-          <a:noFill/>
-          <a:ln>
-            <a:noFill/>
-          </a:ln>
-        </p:spPr>
-        <p:txBody>
-          <a:bodyPr wrap="square" lIns="0" tIns="0" rIns="0" bIns="0" rtlCol="0" anchor="ctr"/>
-          <a:lstStyle/>
-          <a:p>
-            <a:pPr marL="342900" indent="-342900">
-              <a:spcAft>
-                <a:spcPts val="600"/>
-              </a:spcAft>
-              <a:buSzPct val="100000"/>
-              <a:buChar char="▸"/>
-            </a:pPr>
-            <a:r>
-              <a:rPr sz="1300">
-                <a:solidFill>
-                  <a:srgbClr val="475569"/>
-                </a:solidFill>
-                <a:latin typeface="Calibri"/>
-              </a:rPr>
-              <a:t>Le projet vient d’un besoin terrain identifié pendant le DU Engagement.</a:t>
-            </a:r>
-            <a:endParaRPr lang="en-US" sz="1300" dirty="0"/>
-          </a:p>
-          <a:p>
-            <a:r>
-              <a:rPr sz="1300">
-                <a:solidFill>
-                  <a:srgbClr val="475569"/>
-                </a:solidFill>
-                <a:latin typeface="Calibri"/>
-              </a:rPr>
-              <a:t>Le prototype existe déjà : carte, formulaires, rapports et parcours utilisateurs.</a:t>
-            </a:r>
-          </a:p>
-          <a:p>
-            <a:r>
-              <a:rPr sz="1300">
-                <a:solidFill>
-                  <a:srgbClr val="475569"/>
-                </a:solidFill>
-                <a:latin typeface="Calibri"/>
-              </a:rPr>
-              <a:t>L’enjeu de l’année : tester, cadrer et ouvrir le projet à des partenaires.</a:t>
-            </a:r>
+          <a:lstStyle/>
+          <a:p>
+            <a:endParaRPr/>
           </a:p>
         </p:txBody>
       </p:sp>
@@ -2300,7 +1961,7 @@
               </a:rPr>
               <a:t>2</a:t>
             </a:r>
-            <a:endParaRPr lang="en-US" sz="900" dirty="0"/>
+            <a:endParaRPr lang="en-US" sz="900"/>
           </a:p>
         </p:txBody>
       </p:sp>
@@ -2397,7 +2058,7 @@
               <a:buNone/>
             </a:pPr>
             <a:r>
-              <a:rPr lang="en-US" sz="900" dirty="0">
+              <a:rPr lang="en-US" sz="900">
                 <a:solidFill>
                   <a:srgbClr val="475569"/>
                 </a:solidFill>
@@ -2407,7 +2068,7 @@
               </a:rPr>
               <a:t>Pépite Sorbonne Université  ·  SNEE/D2E — Dossier de candidature</a:t>
             </a:r>
-            <a:endParaRPr lang="en-US" sz="900" dirty="0"/>
+            <a:endParaRPr lang="en-US" sz="900"/>
           </a:p>
         </p:txBody>
       </p:sp>
@@ -2444,6 +2105,683 @@
           </a:fontRef>
         </p:style>
       </p:cxnSp>
+      <p:sp>
+        <p:nvSpPr>
+          <p:cNvPr id="4" name="Text 6">
+            <a:extLst>
+              <a:ext uri="{FF2B5EF4-FFF2-40B4-BE49-F238E27FC236}">
+                <a16:creationId xmlns:a16="http://schemas.microsoft.com/office/drawing/2014/main" id="{22DFF388-EB0B-B987-5BE0-E35566E06FC0}"/>
+              </a:ext>
+            </a:extLst>
+          </p:cNvPr>
+          <p:cNvSpPr/>
+          <p:nvPr/>
+        </p:nvSpPr>
+        <p:spPr>
+          <a:xfrm>
+            <a:off x="2978840" y="3517259"/>
+            <a:ext cx="6307907" cy="452844"/>
+          </a:xfrm>
+          <a:prstGeom prst="rect">
+            <a:avLst/>
+          </a:prstGeom>
+          <a:noFill/>
+          <a:ln/>
+        </p:spPr>
+        <p:txBody>
+          <a:bodyPr wrap="square" lIns="0" tIns="0" rIns="0" bIns="0" rtlCol="0" anchor="ctr"/>
+          <a:lstStyle>
+            <a:lvl1pPr marL="0" algn="l" defTabSz="914400" rtl="0" eaLnBrk="1" latinLnBrk="0" hangingPunct="1">
+              <a:defRPr sz="1800" kern="1200">
+                <a:solidFill>
+                  <a:schemeClr val="tx1"/>
+                </a:solidFill>
+                <a:latin typeface="+mn-lt"/>
+                <a:ea typeface="+mn-ea"/>
+                <a:cs typeface="+mn-cs"/>
+              </a:defRPr>
+            </a:lvl1pPr>
+            <a:lvl2pPr marL="457200" algn="l" defTabSz="914400" rtl="0" eaLnBrk="1" latinLnBrk="0" hangingPunct="1">
+              <a:defRPr sz="1800" kern="1200">
+                <a:solidFill>
+                  <a:schemeClr val="tx1"/>
+                </a:solidFill>
+                <a:latin typeface="+mn-lt"/>
+                <a:ea typeface="+mn-ea"/>
+                <a:cs typeface="+mn-cs"/>
+              </a:defRPr>
+            </a:lvl2pPr>
+            <a:lvl3pPr marL="914400" algn="l" defTabSz="914400" rtl="0" eaLnBrk="1" latinLnBrk="0" hangingPunct="1">
+              <a:defRPr sz="1800" kern="1200">
+                <a:solidFill>
+                  <a:schemeClr val="tx1"/>
+                </a:solidFill>
+                <a:latin typeface="+mn-lt"/>
+                <a:ea typeface="+mn-ea"/>
+                <a:cs typeface="+mn-cs"/>
+              </a:defRPr>
+            </a:lvl3pPr>
+            <a:lvl4pPr marL="1371600" algn="l" defTabSz="914400" rtl="0" eaLnBrk="1" latinLnBrk="0" hangingPunct="1">
+              <a:defRPr sz="1800" kern="1200">
+                <a:solidFill>
+                  <a:schemeClr val="tx1"/>
+                </a:solidFill>
+                <a:latin typeface="+mn-lt"/>
+                <a:ea typeface="+mn-ea"/>
+                <a:cs typeface="+mn-cs"/>
+              </a:defRPr>
+            </a:lvl4pPr>
+            <a:lvl5pPr marL="1828800" algn="l" defTabSz="914400" rtl="0" eaLnBrk="1" latinLnBrk="0" hangingPunct="1">
+              <a:defRPr sz="1800" kern="1200">
+                <a:solidFill>
+                  <a:schemeClr val="tx1"/>
+                </a:solidFill>
+                <a:latin typeface="+mn-lt"/>
+                <a:ea typeface="+mn-ea"/>
+                <a:cs typeface="+mn-cs"/>
+              </a:defRPr>
+            </a:lvl5pPr>
+            <a:lvl6pPr marL="2286000" algn="l" defTabSz="914400" rtl="0" eaLnBrk="1" latinLnBrk="0" hangingPunct="1">
+              <a:defRPr sz="1800" kern="1200">
+                <a:solidFill>
+                  <a:schemeClr val="tx1"/>
+                </a:solidFill>
+                <a:latin typeface="+mn-lt"/>
+                <a:ea typeface="+mn-ea"/>
+                <a:cs typeface="+mn-cs"/>
+              </a:defRPr>
+            </a:lvl6pPr>
+            <a:lvl7pPr marL="2743200" algn="l" defTabSz="914400" rtl="0" eaLnBrk="1" latinLnBrk="0" hangingPunct="1">
+              <a:defRPr sz="1800" kern="1200">
+                <a:solidFill>
+                  <a:schemeClr val="tx1"/>
+                </a:solidFill>
+                <a:latin typeface="+mn-lt"/>
+                <a:ea typeface="+mn-ea"/>
+                <a:cs typeface="+mn-cs"/>
+              </a:defRPr>
+            </a:lvl7pPr>
+            <a:lvl8pPr marL="3200400" algn="l" defTabSz="914400" rtl="0" eaLnBrk="1" latinLnBrk="0" hangingPunct="1">
+              <a:defRPr sz="1800" kern="1200">
+                <a:solidFill>
+                  <a:schemeClr val="tx1"/>
+                </a:solidFill>
+                <a:latin typeface="+mn-lt"/>
+                <a:ea typeface="+mn-ea"/>
+                <a:cs typeface="+mn-cs"/>
+              </a:defRPr>
+            </a:lvl8pPr>
+            <a:lvl9pPr marL="3657600" algn="l" defTabSz="914400" rtl="0" eaLnBrk="1" latinLnBrk="0" hangingPunct="1">
+              <a:defRPr sz="1800" kern="1200">
+                <a:solidFill>
+                  <a:schemeClr val="tx1"/>
+                </a:solidFill>
+                <a:latin typeface="+mn-lt"/>
+                <a:ea typeface="+mn-ea"/>
+                <a:cs typeface="+mn-cs"/>
+              </a:defRPr>
+            </a:lvl9pPr>
+          </a:lstStyle>
+          <a:p>
+            <a:pPr algn="ctr"/>
+            <a:r>
+              <a:rPr lang="en-US" sz="2000" b="1">
+                <a:solidFill>
+                  <a:schemeClr val="accent6">
+                    <a:lumMod val="49000"/>
+                  </a:schemeClr>
+                </a:solidFill>
+                <a:latin typeface="Calibri"/>
+                <a:ea typeface="Calibri"/>
+                <a:cs typeface="Calibri"/>
+              </a:rPr>
+              <a:t>DEROOME Maxence</a:t>
+            </a:r>
+            <a:endParaRPr lang="fr-FR" sz="2400">
+              <a:solidFill>
+                <a:schemeClr val="accent6">
+                  <a:lumMod val="49000"/>
+                </a:schemeClr>
+              </a:solidFill>
+              <a:ea typeface="Calibri"/>
+              <a:cs typeface="Calibri"/>
+            </a:endParaRPr>
+          </a:p>
+        </p:txBody>
+      </p:sp>
+      <p:sp>
+        <p:nvSpPr>
+          <p:cNvPr id="20" name="Text 7">
+            <a:extLst>
+              <a:ext uri="{FF2B5EF4-FFF2-40B4-BE49-F238E27FC236}">
+                <a16:creationId xmlns:a16="http://schemas.microsoft.com/office/drawing/2014/main" id="{3CEDE398-9B68-105E-FE56-D9B96A1153A6}"/>
+              </a:ext>
+            </a:extLst>
+          </p:cNvPr>
+          <p:cNvSpPr/>
+          <p:nvPr/>
+        </p:nvSpPr>
+        <p:spPr>
+          <a:xfrm>
+            <a:off x="32042" y="3967820"/>
+            <a:ext cx="12215220" cy="399869"/>
+          </a:xfrm>
+          <a:prstGeom prst="rect">
+            <a:avLst/>
+          </a:prstGeom>
+          <a:noFill/>
+          <a:ln/>
+        </p:spPr>
+        <p:txBody>
+          <a:bodyPr wrap="square" lIns="0" tIns="0" rIns="0" bIns="0" rtlCol="0" anchor="ctr"/>
+          <a:lstStyle>
+            <a:lvl1pPr marL="0" algn="l" defTabSz="914400" rtl="0" eaLnBrk="1" latinLnBrk="0" hangingPunct="1">
+              <a:defRPr sz="1800" kern="1200">
+                <a:solidFill>
+                  <a:schemeClr val="tx1"/>
+                </a:solidFill>
+                <a:latin typeface="+mn-lt"/>
+                <a:ea typeface="+mn-ea"/>
+                <a:cs typeface="+mn-cs"/>
+              </a:defRPr>
+            </a:lvl1pPr>
+            <a:lvl2pPr marL="457200" algn="l" defTabSz="914400" rtl="0" eaLnBrk="1" latinLnBrk="0" hangingPunct="1">
+              <a:defRPr sz="1800" kern="1200">
+                <a:solidFill>
+                  <a:schemeClr val="tx1"/>
+                </a:solidFill>
+                <a:latin typeface="+mn-lt"/>
+                <a:ea typeface="+mn-ea"/>
+                <a:cs typeface="+mn-cs"/>
+              </a:defRPr>
+            </a:lvl2pPr>
+            <a:lvl3pPr marL="914400" algn="l" defTabSz="914400" rtl="0" eaLnBrk="1" latinLnBrk="0" hangingPunct="1">
+              <a:defRPr sz="1800" kern="1200">
+                <a:solidFill>
+                  <a:schemeClr val="tx1"/>
+                </a:solidFill>
+                <a:latin typeface="+mn-lt"/>
+                <a:ea typeface="+mn-ea"/>
+                <a:cs typeface="+mn-cs"/>
+              </a:defRPr>
+            </a:lvl3pPr>
+            <a:lvl4pPr marL="1371600" algn="l" defTabSz="914400" rtl="0" eaLnBrk="1" latinLnBrk="0" hangingPunct="1">
+              <a:defRPr sz="1800" kern="1200">
+                <a:solidFill>
+                  <a:schemeClr val="tx1"/>
+                </a:solidFill>
+                <a:latin typeface="+mn-lt"/>
+                <a:ea typeface="+mn-ea"/>
+                <a:cs typeface="+mn-cs"/>
+              </a:defRPr>
+            </a:lvl4pPr>
+            <a:lvl5pPr marL="1828800" algn="l" defTabSz="914400" rtl="0" eaLnBrk="1" latinLnBrk="0" hangingPunct="1">
+              <a:defRPr sz="1800" kern="1200">
+                <a:solidFill>
+                  <a:schemeClr val="tx1"/>
+                </a:solidFill>
+                <a:latin typeface="+mn-lt"/>
+                <a:ea typeface="+mn-ea"/>
+                <a:cs typeface="+mn-cs"/>
+              </a:defRPr>
+            </a:lvl5pPr>
+            <a:lvl6pPr marL="2286000" algn="l" defTabSz="914400" rtl="0" eaLnBrk="1" latinLnBrk="0" hangingPunct="1">
+              <a:defRPr sz="1800" kern="1200">
+                <a:solidFill>
+                  <a:schemeClr val="tx1"/>
+                </a:solidFill>
+                <a:latin typeface="+mn-lt"/>
+                <a:ea typeface="+mn-ea"/>
+                <a:cs typeface="+mn-cs"/>
+              </a:defRPr>
+            </a:lvl6pPr>
+            <a:lvl7pPr marL="2743200" algn="l" defTabSz="914400" rtl="0" eaLnBrk="1" latinLnBrk="0" hangingPunct="1">
+              <a:defRPr sz="1800" kern="1200">
+                <a:solidFill>
+                  <a:schemeClr val="tx1"/>
+                </a:solidFill>
+                <a:latin typeface="+mn-lt"/>
+                <a:ea typeface="+mn-ea"/>
+                <a:cs typeface="+mn-cs"/>
+              </a:defRPr>
+            </a:lvl7pPr>
+            <a:lvl8pPr marL="3200400" algn="l" defTabSz="914400" rtl="0" eaLnBrk="1" latinLnBrk="0" hangingPunct="1">
+              <a:defRPr sz="1800" kern="1200">
+                <a:solidFill>
+                  <a:schemeClr val="tx1"/>
+                </a:solidFill>
+                <a:latin typeface="+mn-lt"/>
+                <a:ea typeface="+mn-ea"/>
+                <a:cs typeface="+mn-cs"/>
+              </a:defRPr>
+            </a:lvl8pPr>
+            <a:lvl9pPr marL="3657600" algn="l" defTabSz="914400" rtl="0" eaLnBrk="1" latinLnBrk="0" hangingPunct="1">
+              <a:defRPr sz="1800" kern="1200">
+                <a:solidFill>
+                  <a:schemeClr val="tx1"/>
+                </a:solidFill>
+                <a:latin typeface="+mn-lt"/>
+                <a:ea typeface="+mn-ea"/>
+                <a:cs typeface="+mn-cs"/>
+              </a:defRPr>
+            </a:lvl9pPr>
+          </a:lstStyle>
+          <a:p>
+            <a:pPr algn="ctr"/>
+            <a:r>
+              <a:rPr lang="en-US" b="1" err="1">
+                <a:solidFill>
+                  <a:schemeClr val="accent6">
+                    <a:lumMod val="76000"/>
+                  </a:schemeClr>
+                </a:solidFill>
+                <a:ea typeface="+mn-lt"/>
+                <a:cs typeface="+mn-lt"/>
+              </a:rPr>
+              <a:t>Responsable</a:t>
+            </a:r>
+            <a:r>
+              <a:rPr lang="en-US" b="1">
+                <a:solidFill>
+                  <a:schemeClr val="accent6">
+                    <a:lumMod val="76000"/>
+                  </a:schemeClr>
+                </a:solidFill>
+                <a:ea typeface="+mn-lt"/>
+                <a:cs typeface="+mn-lt"/>
+              </a:rPr>
+              <a:t> du </a:t>
+            </a:r>
+            <a:r>
+              <a:rPr lang="en-US" b="1" err="1">
+                <a:solidFill>
+                  <a:schemeClr val="accent6">
+                    <a:lumMod val="76000"/>
+                  </a:schemeClr>
+                </a:solidFill>
+                <a:ea typeface="+mn-lt"/>
+                <a:cs typeface="+mn-lt"/>
+              </a:rPr>
+              <a:t>projet</a:t>
+            </a:r>
+            <a:br>
+              <a:rPr lang="en-US" b="1">
+                <a:ea typeface="+mn-lt"/>
+                <a:cs typeface="+mn-lt"/>
+              </a:rPr>
+            </a:br>
+            <a:endParaRPr lang="en-US" b="1">
+              <a:solidFill>
+                <a:schemeClr val="accent6">
+                  <a:lumMod val="76000"/>
+                </a:schemeClr>
+              </a:solidFill>
+              <a:ea typeface="+mn-lt"/>
+              <a:cs typeface="+mn-lt"/>
+            </a:endParaRPr>
+          </a:p>
+        </p:txBody>
+      </p:sp>
+      <p:sp>
+        <p:nvSpPr>
+          <p:cNvPr id="22" name="Text 8">
+            <a:extLst>
+              <a:ext uri="{FF2B5EF4-FFF2-40B4-BE49-F238E27FC236}">
+                <a16:creationId xmlns:a16="http://schemas.microsoft.com/office/drawing/2014/main" id="{DBE748E5-03D4-2E39-1987-2426C30EB132}"/>
+              </a:ext>
+            </a:extLst>
+          </p:cNvPr>
+          <p:cNvSpPr/>
+          <p:nvPr/>
+        </p:nvSpPr>
+        <p:spPr>
+          <a:xfrm>
+            <a:off x="3390293" y="4162481"/>
+            <a:ext cx="6306453" cy="1629952"/>
+          </a:xfrm>
+          <a:prstGeom prst="rect">
+            <a:avLst/>
+          </a:prstGeom>
+          <a:noFill/>
+          <a:ln/>
+        </p:spPr>
+        <p:txBody>
+          <a:bodyPr wrap="square" lIns="0" tIns="0" rIns="0" bIns="0" rtlCol="0" anchor="ctr"/>
+          <a:lstStyle>
+            <a:lvl1pPr marL="0" algn="l" defTabSz="914400" rtl="0" eaLnBrk="1" latinLnBrk="0" hangingPunct="1">
+              <a:defRPr sz="1800" kern="1200">
+                <a:solidFill>
+                  <a:schemeClr val="tx1"/>
+                </a:solidFill>
+                <a:latin typeface="+mn-lt"/>
+                <a:ea typeface="+mn-ea"/>
+                <a:cs typeface="+mn-cs"/>
+              </a:defRPr>
+            </a:lvl1pPr>
+            <a:lvl2pPr marL="457200" algn="l" defTabSz="914400" rtl="0" eaLnBrk="1" latinLnBrk="0" hangingPunct="1">
+              <a:defRPr sz="1800" kern="1200">
+                <a:solidFill>
+                  <a:schemeClr val="tx1"/>
+                </a:solidFill>
+                <a:latin typeface="+mn-lt"/>
+                <a:ea typeface="+mn-ea"/>
+                <a:cs typeface="+mn-cs"/>
+              </a:defRPr>
+            </a:lvl2pPr>
+            <a:lvl3pPr marL="914400" algn="l" defTabSz="914400" rtl="0" eaLnBrk="1" latinLnBrk="0" hangingPunct="1">
+              <a:defRPr sz="1800" kern="1200">
+                <a:solidFill>
+                  <a:schemeClr val="tx1"/>
+                </a:solidFill>
+                <a:latin typeface="+mn-lt"/>
+                <a:ea typeface="+mn-ea"/>
+                <a:cs typeface="+mn-cs"/>
+              </a:defRPr>
+            </a:lvl3pPr>
+            <a:lvl4pPr marL="1371600" algn="l" defTabSz="914400" rtl="0" eaLnBrk="1" latinLnBrk="0" hangingPunct="1">
+              <a:defRPr sz="1800" kern="1200">
+                <a:solidFill>
+                  <a:schemeClr val="tx1"/>
+                </a:solidFill>
+                <a:latin typeface="+mn-lt"/>
+                <a:ea typeface="+mn-ea"/>
+                <a:cs typeface="+mn-cs"/>
+              </a:defRPr>
+            </a:lvl4pPr>
+            <a:lvl5pPr marL="1828800" algn="l" defTabSz="914400" rtl="0" eaLnBrk="1" latinLnBrk="0" hangingPunct="1">
+              <a:defRPr sz="1800" kern="1200">
+                <a:solidFill>
+                  <a:schemeClr val="tx1"/>
+                </a:solidFill>
+                <a:latin typeface="+mn-lt"/>
+                <a:ea typeface="+mn-ea"/>
+                <a:cs typeface="+mn-cs"/>
+              </a:defRPr>
+            </a:lvl5pPr>
+            <a:lvl6pPr marL="2286000" algn="l" defTabSz="914400" rtl="0" eaLnBrk="1" latinLnBrk="0" hangingPunct="1">
+              <a:defRPr sz="1800" kern="1200">
+                <a:solidFill>
+                  <a:schemeClr val="tx1"/>
+                </a:solidFill>
+                <a:latin typeface="+mn-lt"/>
+                <a:ea typeface="+mn-ea"/>
+                <a:cs typeface="+mn-cs"/>
+              </a:defRPr>
+            </a:lvl6pPr>
+            <a:lvl7pPr marL="2743200" algn="l" defTabSz="914400" rtl="0" eaLnBrk="1" latinLnBrk="0" hangingPunct="1">
+              <a:defRPr sz="1800" kern="1200">
+                <a:solidFill>
+                  <a:schemeClr val="tx1"/>
+                </a:solidFill>
+                <a:latin typeface="+mn-lt"/>
+                <a:ea typeface="+mn-ea"/>
+                <a:cs typeface="+mn-cs"/>
+              </a:defRPr>
+            </a:lvl7pPr>
+            <a:lvl8pPr marL="3200400" algn="l" defTabSz="914400" rtl="0" eaLnBrk="1" latinLnBrk="0" hangingPunct="1">
+              <a:defRPr sz="1800" kern="1200">
+                <a:solidFill>
+                  <a:schemeClr val="tx1"/>
+                </a:solidFill>
+                <a:latin typeface="+mn-lt"/>
+                <a:ea typeface="+mn-ea"/>
+                <a:cs typeface="+mn-cs"/>
+              </a:defRPr>
+            </a:lvl8pPr>
+            <a:lvl9pPr marL="3657600" algn="l" defTabSz="914400" rtl="0" eaLnBrk="1" latinLnBrk="0" hangingPunct="1">
+              <a:defRPr sz="1800" kern="1200">
+                <a:solidFill>
+                  <a:schemeClr val="tx1"/>
+                </a:solidFill>
+                <a:latin typeface="+mn-lt"/>
+                <a:ea typeface="+mn-ea"/>
+                <a:cs typeface="+mn-cs"/>
+              </a:defRPr>
+            </a:lvl9pPr>
+          </a:lstStyle>
+          <a:p>
+            <a:pPr marL="285750" indent="-285750">
+              <a:spcBef>
+                <a:spcPts val="300"/>
+              </a:spcBef>
+              <a:spcAft>
+                <a:spcPts val="300"/>
+              </a:spcAft>
+              <a:buFont typeface="Calibri"/>
+              <a:buChar char="-"/>
+            </a:pPr>
+            <a:r>
+              <a:rPr lang="en-US" sz="1400" err="1">
+                <a:ea typeface="+mn-lt"/>
+                <a:cs typeface="+mn-lt"/>
+              </a:rPr>
+              <a:t>Bénévole</a:t>
+            </a:r>
+            <a:r>
+              <a:rPr lang="en-US" sz="1400">
+                <a:ea typeface="+mn-lt"/>
+                <a:cs typeface="+mn-lt"/>
+              </a:rPr>
+              <a:t> </a:t>
+            </a:r>
+            <a:r>
+              <a:rPr lang="en-US" sz="1400" err="1">
+                <a:ea typeface="+mn-lt"/>
+                <a:cs typeface="+mn-lt"/>
+              </a:rPr>
+              <a:t>actif</a:t>
+            </a:r>
+            <a:r>
+              <a:rPr lang="en-US" sz="1400">
+                <a:ea typeface="+mn-lt"/>
+                <a:cs typeface="+mn-lt"/>
+              </a:rPr>
+              <a:t> sur </a:t>
+            </a:r>
+            <a:r>
+              <a:rPr lang="en-US" sz="1400" err="1">
+                <a:ea typeface="+mn-lt"/>
+                <a:cs typeface="+mn-lt"/>
+              </a:rPr>
+              <a:t>des</a:t>
+            </a:r>
+            <a:r>
+              <a:rPr lang="en-US" sz="1400">
+                <a:ea typeface="+mn-lt"/>
+                <a:cs typeface="+mn-lt"/>
+              </a:rPr>
+              <a:t> </a:t>
+            </a:r>
+            <a:r>
+              <a:rPr lang="en-US" sz="1400" err="1">
+                <a:ea typeface="+mn-lt"/>
+                <a:cs typeface="+mn-lt"/>
+              </a:rPr>
+              <a:t>cleanwalk</a:t>
+            </a:r>
+            <a:endParaRPr lang="fr-FR" err="1"/>
+          </a:p>
+          <a:p>
+            <a:pPr marL="285750" indent="-285750">
+              <a:spcBef>
+                <a:spcPts val="300"/>
+              </a:spcBef>
+              <a:spcAft>
+                <a:spcPts val="300"/>
+              </a:spcAft>
+              <a:buFont typeface="Calibri"/>
+              <a:buChar char="-"/>
+            </a:pPr>
+            <a:r>
+              <a:rPr lang="en-US" sz="1400" err="1">
+                <a:ea typeface="+mn-lt"/>
+                <a:cs typeface="+mn-lt"/>
+              </a:rPr>
+              <a:t>Compétences</a:t>
+            </a:r>
+            <a:r>
+              <a:rPr lang="en-US" sz="1400">
+                <a:ea typeface="+mn-lt"/>
+                <a:cs typeface="+mn-lt"/>
+              </a:rPr>
+              <a:t> </a:t>
+            </a:r>
+            <a:r>
+              <a:rPr lang="en-US" sz="1400" err="1">
+                <a:ea typeface="+mn-lt"/>
+                <a:cs typeface="+mn-lt"/>
+              </a:rPr>
+              <a:t>en</a:t>
+            </a:r>
+            <a:r>
+              <a:rPr lang="en-US" sz="1400">
+                <a:ea typeface="+mn-lt"/>
+                <a:cs typeface="+mn-lt"/>
+              </a:rPr>
+              <a:t> </a:t>
+            </a:r>
+            <a:r>
+              <a:rPr lang="en-US" sz="1400" err="1">
+                <a:ea typeface="+mn-lt"/>
+                <a:cs typeface="+mn-lt"/>
+              </a:rPr>
+              <a:t>développement</a:t>
+            </a:r>
+            <a:r>
+              <a:rPr lang="en-US" sz="1400">
+                <a:ea typeface="+mn-lt"/>
+                <a:cs typeface="+mn-lt"/>
+              </a:rPr>
+              <a:t> web </a:t>
+            </a:r>
+          </a:p>
+          <a:p>
+            <a:pPr marL="285750" indent="-285750">
+              <a:spcBef>
+                <a:spcPts val="300"/>
+              </a:spcBef>
+              <a:spcAft>
+                <a:spcPts val="300"/>
+              </a:spcAft>
+              <a:buFont typeface="Calibri"/>
+              <a:buChar char="-"/>
+            </a:pPr>
+            <a:r>
+              <a:rPr lang="en-US" sz="1400" err="1">
+                <a:ea typeface="+mn-lt"/>
+                <a:cs typeface="+mn-lt"/>
+              </a:rPr>
+              <a:t>Compétences</a:t>
+            </a:r>
+            <a:r>
+              <a:rPr lang="en-US" sz="1400">
+                <a:ea typeface="+mn-lt"/>
+                <a:cs typeface="+mn-lt"/>
+              </a:rPr>
+              <a:t> </a:t>
+            </a:r>
+            <a:r>
+              <a:rPr lang="en-US" sz="1400" err="1">
+                <a:ea typeface="+mn-lt"/>
+                <a:cs typeface="+mn-lt"/>
+              </a:rPr>
+              <a:t>en</a:t>
+            </a:r>
+            <a:r>
+              <a:rPr lang="en-US" sz="1400">
+                <a:ea typeface="+mn-lt"/>
+                <a:cs typeface="+mn-lt"/>
+              </a:rPr>
+              <a:t> </a:t>
+            </a:r>
+            <a:r>
+              <a:rPr lang="en-US" sz="1400" err="1">
+                <a:ea typeface="+mn-lt"/>
+                <a:cs typeface="+mn-lt"/>
+              </a:rPr>
+              <a:t>utilisation</a:t>
+            </a:r>
+            <a:r>
+              <a:rPr lang="en-US" sz="1400">
+                <a:ea typeface="+mn-lt"/>
+                <a:cs typeface="+mn-lt"/>
+              </a:rPr>
+              <a:t> de </a:t>
+            </a:r>
+            <a:r>
+              <a:rPr lang="en-US" sz="1400" err="1">
+                <a:ea typeface="+mn-lt"/>
+                <a:cs typeface="+mn-lt"/>
+              </a:rPr>
+              <a:t>l'IA</a:t>
+            </a:r>
+            <a:r>
+              <a:rPr lang="en-US" sz="1400">
+                <a:ea typeface="+mn-lt"/>
+                <a:cs typeface="+mn-lt"/>
+              </a:rPr>
+              <a:t> </a:t>
+            </a:r>
+            <a:r>
+              <a:rPr lang="en-US" sz="1400" err="1">
+                <a:ea typeface="+mn-lt"/>
+                <a:cs typeface="+mn-lt"/>
+              </a:rPr>
+              <a:t>agentique</a:t>
+            </a:r>
+            <a:endParaRPr lang="en-US" sz="1400">
+              <a:ea typeface="+mn-lt"/>
+              <a:cs typeface="+mn-lt"/>
+            </a:endParaRPr>
+          </a:p>
+          <a:p>
+            <a:pPr marL="285750" indent="-285750">
+              <a:spcBef>
+                <a:spcPts val="300"/>
+              </a:spcBef>
+              <a:spcAft>
+                <a:spcPts val="300"/>
+              </a:spcAft>
+              <a:buFont typeface="Calibri"/>
+              <a:buChar char="-"/>
+            </a:pPr>
+            <a:endParaRPr lang="en-US" sz="1400">
+              <a:ea typeface="+mn-lt"/>
+              <a:cs typeface="+mn-lt"/>
+            </a:endParaRPr>
+          </a:p>
+        </p:txBody>
+      </p:sp>
+      <p:pic>
+        <p:nvPicPr>
+          <p:cNvPr id="23" name="Image 22" descr="Une image contenant Visage humain, personne, sourire, homme&#10;&#10;Le contenu généré par l’IA peut être incorrect.">
+            <a:extLst>
+              <a:ext uri="{FF2B5EF4-FFF2-40B4-BE49-F238E27FC236}">
+                <a16:creationId xmlns:a16="http://schemas.microsoft.com/office/drawing/2014/main" id="{E876AF28-2B6C-58A2-4568-6FA1F621BE72}"/>
+              </a:ext>
+            </a:extLst>
+          </p:cNvPr>
+          <p:cNvPicPr>
+            <a:picLocks noChangeAspect="1"/>
+          </p:cNvPicPr>
+          <p:nvPr/>
+        </p:nvPicPr>
+        <p:blipFill>
+          <a:blip r:embed="rId5"/>
+          <a:stretch>
+            <a:fillRect/>
+          </a:stretch>
+        </p:blipFill>
+        <p:spPr>
+          <a:xfrm>
+            <a:off x="5376201" y="1559354"/>
+            <a:ext cx="1509485" cy="1834240"/>
+          </a:xfrm>
+          <a:prstGeom prst="rect">
+            <a:avLst/>
+          </a:prstGeom>
+        </p:spPr>
+      </p:pic>
     </p:spTree>
   </p:cSld>
   <p:clrMapOvr>
@@ -2500,18 +2838,15 @@
           <a:bodyPr wrap="square" lIns="0" tIns="0" rIns="0" bIns="0" rtlCol="0" anchor="ctr"/>
           <a:lstStyle/>
           <a:p>
-            <a:pPr marL="0" indent="0">
-              <a:buNone/>
-            </a:pPr>
-            <a:r>
-              <a:rPr sz="2800" b="1">
+            <a:r>
+              <a:rPr sz="2800" b="1" i="0">
                 <a:solidFill>
                   <a:srgbClr val="064E3B"/>
                 </a:solidFill>
-              </a:rPr>
-              <a:t>D'où vient l'idée du projet ?</a:t>
-            </a:r>
-            <a:endParaRPr lang="en-US" sz="2800" dirty="0"/>
+                <a:latin typeface="Calibri"/>
+              </a:rPr>
+              <a:t>Pourquoi CleanMyMap ?</a:t>
+            </a:r>
           </a:p>
         </p:txBody>
       </p:sp>
@@ -2538,19 +2873,15 @@
           <a:bodyPr wrap="square" lIns="0" tIns="0" rIns="0" bIns="0" rtlCol="0" anchor="ctr"/>
           <a:lstStyle/>
           <a:p>
-            <a:pPr marL="0" indent="0">
-              <a:buNone/>
-            </a:pPr>
-            <a:r>
-              <a:rPr sz="1400" i="1">
-                <a:solidFill>
-                  <a:srgbClr val="475569"/>
-                </a:solidFill>
-                <a:latin typeface="Calibri"/>
-              </a:rPr>
-              <a:t>Storytelling — une action locale visible, mais difficile à coordonner et à prouver</a:t>
-            </a:r>
-            <a:endParaRPr lang="en-US" sz="1400" dirty="0"/>
+            <a:r>
+              <a:rPr sz="1400" b="0" i="1">
+                <a:solidFill>
+                  <a:srgbClr val="475569"/>
+                </a:solidFill>
+                <a:latin typeface="Calibri"/>
+              </a:rPr>
+              <a:t>Un projet associatif né du terrain et centré sur la valorisation des bénévoles</a:t>
+            </a:r>
           </a:p>
         </p:txBody>
       </p:sp>
@@ -2579,7 +2910,10 @@
         </p:spPr>
         <p:txBody>
           <a:bodyPr/>
-          <a:p/>
+          <a:lstStyle/>
+          <a:p>
+            <a:endParaRPr/>
+          </a:p>
         </p:txBody>
       </p:sp>
       <p:sp>
@@ -2605,19 +2939,15 @@
           <a:bodyPr wrap="square" lIns="0" tIns="0" rIns="0" bIns="0" rtlCol="0" anchor="ctr"/>
           <a:lstStyle/>
           <a:p>
-            <a:pPr marL="0" indent="0">
-              <a:buNone/>
-            </a:pPr>
-            <a:r>
-              <a:rPr sz="1500" b="1">
+            <a:r>
+              <a:rPr sz="1500" b="1" i="0">
                 <a:solidFill>
                   <a:srgbClr val="10B981"/>
                 </a:solidFill>
                 <a:latin typeface="Calibri"/>
               </a:rPr>
-              <a:t>Constat terrain</a:t>
-            </a:r>
-            <a:endParaRPr lang="en-US" sz="1500" dirty="0"/>
+              <a:t>Origine du projet</a:t>
+            </a:r>
           </a:p>
         </p:txBody>
       </p:sp>
@@ -2644,99 +2974,38 @@
           <a:bodyPr wrap="square" lIns="0" tIns="0" rIns="0" bIns="0" rtlCol="0" anchor="ctr"/>
           <a:lstStyle/>
           <a:p>
-            <a:pPr marL="342900" indent="-342900">
-              <a:spcAft>
-                <a:spcPts val="600"/>
-              </a:spcAft>
-              <a:buSzPct val="100000"/>
-              <a:buChar char="▸"/>
-            </a:pPr>
-            <a:r>
-              <a:rPr sz="1300">
-                <a:solidFill>
-                  <a:srgbClr val="475569"/>
-                </a:solidFill>
-                <a:latin typeface="Calibri"/>
-              </a:rPr>
-              <a:t>Les déchets sont visibles dans l’espace public, mais les informations restent dispersées.</a:t>
-            </a:r>
-            <a:endParaRPr lang="en-US" sz="1300" dirty="0"/>
-          </a:p>
-          <a:p>
-            <a:r>
-              <a:rPr sz="1300">
-                <a:solidFill>
-                  <a:srgbClr val="475569"/>
-                </a:solidFill>
-                <a:latin typeface="Calibri"/>
-              </a:rPr>
-              <a:t/>
-            </a:r>
-          </a:p>
-          <a:p>
-            <a:r>
-              <a:rPr sz="1300">
-                <a:solidFill>
-                  <a:srgbClr val="475569"/>
-                </a:solidFill>
-                <a:latin typeface="Calibri"/>
-              </a:rPr>
-              <a:t>Trois freins reviennent souvent :</a:t>
-            </a:r>
-          </a:p>
-          <a:p>
-            <a:r>
-              <a:rPr sz="1300">
-                <a:solidFill>
-                  <a:srgbClr val="475569"/>
-                </a:solidFill>
-                <a:latin typeface="Calibri"/>
-              </a:rPr>
-              <a:t>• savoir où agir en priorité ;</a:t>
-            </a:r>
-          </a:p>
-          <a:p>
-            <a:r>
-              <a:rPr sz="1300">
-                <a:solidFill>
-                  <a:srgbClr val="475569"/>
-                </a:solidFill>
-                <a:latin typeface="Calibri"/>
-              </a:rPr>
-              <a:t>• garder une mobilisation régulière ;</a:t>
-            </a:r>
-          </a:p>
-          <a:p>
-            <a:r>
-              <a:rPr sz="1300">
-                <a:solidFill>
-                  <a:srgbClr val="475569"/>
-                </a:solidFill>
-                <a:latin typeface="Calibri"/>
-              </a:rPr>
-              <a:t>• transformer une action ponctuelle en impact lisible et partageable.</a:t>
-            </a:r>
-          </a:p>
-          <a:p>
-            <a:r>
-              <a:rPr sz="1300">
-                <a:solidFill>
-                  <a:srgbClr val="475569"/>
-                </a:solidFill>
-                <a:latin typeface="Calibri"/>
-              </a:rPr>
-              <a:t/>
-            </a:r>
-          </a:p>
-          <a:p>
-            <a:r>
-              <a:rPr sz="1300">
-                <a:solidFill>
-                  <a:srgbClr val="475569"/>
-                </a:solidFill>
-                <a:latin typeface="Calibri"/>
-              </a:rPr>
-              <a:t>CleanMyMap part de cette question : comment relier bénévoles, associations et acteurs locaux autour d’une donnée terrain simple ?</a:t>
+            <a:r>
+              <a:rPr sz="1250" b="0" i="0">
+                <a:solidFill>
+                  <a:srgbClr val="475569"/>
+                </a:solidFill>
+                <a:latin typeface="Calibri"/>
+              </a:rPr>
+              <a:t>CleanMyMap part d’un constat simple : les actions de dépollution existent, mais elles restent souvent peu visibles une fois terminées.</a:t>
+            </a:r>
+          </a:p>
+          <a:p/>
+          <a:p>
+            <a:r>
+              <a:rPr sz="1250" b="0" i="0">
+                <a:solidFill>
+                  <a:srgbClr val="475569"/>
+                </a:solidFill>
+                <a:latin typeface="Calibri"/>
+              </a:rPr>
+              <a:t>Les bénévoles donnent du temps, repèrent des besoins et produisent un impact concret. Pourtant, cet engagement est rarement cartographié, suivi ou valorisé.</a:t>
+            </a:r>
+          </a:p>
+          <a:p/>
+          <a:p>
+            <a:r>
+              <a:rPr sz="1250" b="0" i="0">
+                <a:solidFill>
+                  <a:srgbClr val="475569"/>
+                </a:solidFill>
+                <a:latin typeface="Calibri"/>
+              </a:rPr>
+              <a:t>L’objectif associatif : aider les acteurs locaux à mieux organiser, documenter et reconnaître les actions de terrain.</a:t>
             </a:r>
           </a:p>
         </p:txBody>
@@ -2766,7 +3035,10 @@
         </p:spPr>
         <p:txBody>
           <a:bodyPr/>
-          <a:p/>
+          <a:lstStyle/>
+          <a:p>
+            <a:endParaRPr/>
+          </a:p>
         </p:txBody>
       </p:sp>
       <p:sp>
@@ -2792,9 +3064,7 @@
           <a:bodyPr wrap="square" lIns="0" tIns="0" rIns="0" bIns="0" rtlCol="0" anchor="ctr"/>
           <a:lstStyle/>
           <a:p>
-            <a:pPr marL="0" indent="0" algn="ctr">
-              <a:buNone/>
-            </a:pPr>
+            <a:pPr algn="ctr"/>
             <a:r>
               <a:rPr sz="1400" b="1" i="1">
                 <a:solidFill>
@@ -2802,11 +3072,11 @@
                 </a:solidFill>
                 <a:latin typeface="Calibri"/>
               </a:rPr>
-              <a:t>Visuel à insérer</a:t>
-            </a:r>
-            <a:endParaRPr lang="en-US" sz="1400" dirty="0"/>
-          </a:p>
-          <a:p>
+              <a:t>À montrer</a:t>
+            </a:r>
+          </a:p>
+          <a:p>
+            <a:pPr algn="ctr"/>
             <a:r>
               <a:rPr sz="1400" b="1" i="1">
                 <a:solidFill>
@@ -2814,7 +3084,7 @@
                 </a:solidFill>
                 <a:latin typeface="Calibri"/>
               </a:rPr>
-              <a:t>Carte / action terrain / chiffre clé</a:t>
+              <a:t>Photo cleanwalk / carte / indicateur bénévole</a:t>
             </a:r>
           </a:p>
         </p:txBody>
@@ -2854,7 +3124,7 @@
               </a:rPr>
               <a:t>3</a:t>
             </a:r>
-            <a:endParaRPr lang="en-US" sz="900" dirty="0"/>
+            <a:endParaRPr lang="en-US" sz="900"/>
           </a:p>
         </p:txBody>
       </p:sp>
@@ -2951,7 +3221,7 @@
               <a:buNone/>
             </a:pPr>
             <a:r>
-              <a:rPr lang="en-US" sz="900" dirty="0">
+              <a:rPr lang="en-US" sz="900">
                 <a:solidFill>
                   <a:srgbClr val="475569"/>
                 </a:solidFill>
@@ -2961,7 +3231,7 @@
               </a:rPr>
               <a:t>Pépite Sorbonne Université  ·  SNEE/D2E — Dossier de candidature</a:t>
             </a:r>
-            <a:endParaRPr lang="en-US" sz="900" dirty="0"/>
+            <a:endParaRPr lang="en-US" sz="900"/>
           </a:p>
         </p:txBody>
       </p:sp>
@@ -3054,18 +3324,15 @@
           <a:bodyPr wrap="square" lIns="0" tIns="0" rIns="0" bIns="0" rtlCol="0" anchor="ctr"/>
           <a:lstStyle/>
           <a:p>
-            <a:pPr marL="0" indent="0">
-              <a:buNone/>
-            </a:pPr>
-            <a:r>
-              <a:rPr sz="2800" b="1">
+            <a:r>
+              <a:rPr sz="2800" b="1" i="0">
                 <a:solidFill>
                   <a:srgbClr val="064E3B"/>
                 </a:solidFill>
-              </a:rPr>
-              <a:t>Présentation de l'offre et du concept</a:t>
-            </a:r>
-            <a:endParaRPr lang="en-US" sz="2800" dirty="0"/>
+                <a:latin typeface="Calibri"/>
+              </a:rPr>
+              <a:t>Quel problème est résolu ?</a:t>
+            </a:r>
           </a:p>
         </p:txBody>
       </p:sp>
@@ -3092,19 +3359,15 @@
           <a:bodyPr wrap="square" lIns="0" tIns="0" rIns="0" bIns="0" rtlCol="0" anchor="ctr"/>
           <a:lstStyle/>
           <a:p>
-            <a:pPr marL="0" indent="0">
-              <a:buNone/>
-            </a:pPr>
-            <a:r>
-              <a:rPr sz="1400" i="1">
-                <a:solidFill>
-                  <a:srgbClr val="475569"/>
-                </a:solidFill>
-                <a:latin typeface="Calibri"/>
-              </a:rPr>
-              <a:t>Une plateforme citoyenne centrée sur la boucle action → donnée → impact</a:t>
-            </a:r>
-            <a:endParaRPr lang="en-US" sz="1400" dirty="0"/>
+            <a:r>
+              <a:rPr sz="1400" b="0" i="1">
+                <a:solidFill>
+                  <a:srgbClr val="475569"/>
+                </a:solidFill>
+                <a:latin typeface="Calibri"/>
+              </a:rPr>
+              <a:t>Rendre les actions locales plus visibles, coordonnées et exploitables</a:t>
+            </a:r>
           </a:p>
         </p:txBody>
       </p:sp>
@@ -3133,7 +3396,10 @@
         </p:spPr>
         <p:txBody>
           <a:bodyPr/>
-          <a:p/>
+          <a:lstStyle/>
+          <a:p>
+            <a:endParaRPr/>
+          </a:p>
         </p:txBody>
       </p:sp>
       <p:sp>
@@ -3159,19 +3425,15 @@
           <a:bodyPr wrap="square" lIns="0" tIns="0" rIns="0" bIns="0" rtlCol="0" anchor="ctr"/>
           <a:lstStyle/>
           <a:p>
-            <a:pPr marL="0" indent="0">
-              <a:buNone/>
-            </a:pPr>
-            <a:r>
-              <a:rPr sz="1500" b="1">
+            <a:r>
+              <a:rPr sz="1500" b="1" i="0">
                 <a:solidFill>
                   <a:srgbClr val="10B981"/>
                 </a:solidFill>
                 <a:latin typeface="Calibri"/>
               </a:rPr>
-              <a:t>Votre solution</a:t>
-            </a:r>
-            <a:endParaRPr lang="en-US" sz="1500" dirty="0"/>
+              <a:t>Problème identifié</a:t>
+            </a:r>
           </a:p>
         </p:txBody>
       </p:sp>
@@ -3198,77 +3460,59 @@
           <a:bodyPr wrap="square" lIns="0" tIns="0" rIns="0" bIns="0" rtlCol="0" anchor="ctr"/>
           <a:lstStyle/>
           <a:p>
-            <a:pPr marL="342900" indent="-342900">
-              <a:spcAft>
-                <a:spcPts val="600"/>
-              </a:spcAft>
-              <a:buSzPct val="100000"/>
-              <a:buChar char="▸"/>
-            </a:pPr>
-            <a:r>
-              <a:rPr sz="1300">
-                <a:solidFill>
-                  <a:srgbClr val="475569"/>
-                </a:solidFill>
-                <a:latin typeface="Calibri"/>
-              </a:rPr>
-              <a:t>CleanMyMap permet de :</a:t>
-            </a:r>
-            <a:endParaRPr lang="en-US" sz="1300" dirty="0"/>
-          </a:p>
-          <a:p>
-            <a:r>
-              <a:rPr sz="1300">
-                <a:solidFill>
-                  <a:srgbClr val="475569"/>
-                </a:solidFill>
-                <a:latin typeface="Calibri"/>
-              </a:rPr>
-              <a:t>• déclarer ou rejoindre une action de dépollution ;</a:t>
-            </a:r>
-          </a:p>
-          <a:p>
-            <a:r>
-              <a:rPr sz="1300">
-                <a:solidFill>
-                  <a:srgbClr val="475569"/>
-                </a:solidFill>
-                <a:latin typeface="Calibri"/>
-              </a:rPr>
-              <a:t>• visualiser les actions et signalements sur une carte ;</a:t>
-            </a:r>
-          </a:p>
-          <a:p>
-            <a:r>
-              <a:rPr sz="1300">
-                <a:solidFill>
-                  <a:srgbClr val="475569"/>
-                </a:solidFill>
-                <a:latin typeface="Calibri"/>
-              </a:rPr>
-              <a:t>• transformer les données terrain en indicateurs, rapports et traces exploitables.</a:t>
-            </a:r>
-          </a:p>
-          <a:p>
-            <a:r>
-              <a:rPr sz="1300">
-                <a:solidFill>
-                  <a:srgbClr val="475569"/>
-                </a:solidFill>
-                <a:latin typeface="Calibri"/>
-              </a:rPr>
-              <a:t/>
-            </a:r>
-          </a:p>
-          <a:p>
-            <a:r>
-              <a:rPr sz="1300">
-                <a:solidFill>
-                  <a:srgbClr val="475569"/>
-                </a:solidFill>
-                <a:latin typeface="Calibri"/>
-              </a:rPr>
-              <a:t>La valeur principale : rendre une action bénévole plus facile à comprendre, à coordonner et à valoriser.</a:t>
+            <a:r>
+              <a:rPr sz="1250" b="0" i="0">
+                <a:solidFill>
+                  <a:srgbClr val="475569"/>
+                </a:solidFill>
+                <a:latin typeface="Calibri"/>
+              </a:rPr>
+              <a:t>Trois limites reviennent dans les actions de dépollution :</a:t>
+            </a:r>
+          </a:p>
+          <a:p>
+            <a:r>
+              <a:rPr sz="1250" b="0" i="0">
+                <a:solidFill>
+                  <a:srgbClr val="475569"/>
+                </a:solidFill>
+                <a:latin typeface="Calibri"/>
+              </a:rPr>
+              <a:t>• informations dispersées entre formulaires, groupes et cartes ;</a:t>
+            </a:r>
+          </a:p>
+          <a:p>
+            <a:r>
+              <a:rPr sz="1250" b="0" i="0">
+                <a:solidFill>
+                  <a:srgbClr val="475569"/>
+                </a:solidFill>
+                <a:latin typeface="Calibri"/>
+              </a:rPr>
+              <a:t>• difficulté à savoir où agir en priorité ;</a:t>
+            </a:r>
+          </a:p>
+          <a:p>
+            <a:r>
+              <a:rPr sz="1250" b="0" i="0">
+                <a:solidFill>
+                  <a:srgbClr val="475569"/>
+                </a:solidFill>
+                <a:latin typeface="Calibri"/>
+              </a:rPr>
+              <a:t>• faible continuité après l’action : peu de trace, peu de preuve, peu de valorisation.</a:t>
+            </a:r>
+          </a:p>
+          <a:p/>
+          <a:p>
+            <a:r>
+              <a:rPr sz="1250" b="0" i="0">
+                <a:solidFill>
+                  <a:srgbClr val="475569"/>
+                </a:solidFill>
+                <a:latin typeface="Calibri"/>
+              </a:rPr>
+              <a:t>CleanMyMap ne remplace pas les associations. La plateforme leur apporte un support commun pour coordonner, suivre et présenter l’impact des bénévoles.</a:t>
             </a:r>
           </a:p>
         </p:txBody>
@@ -3298,7 +3542,10 @@
         </p:spPr>
         <p:txBody>
           <a:bodyPr/>
-          <a:p/>
+          <a:lstStyle/>
+          <a:p>
+            <a:endParaRPr/>
+          </a:p>
         </p:txBody>
       </p:sp>
       <p:sp>
@@ -3324,9 +3571,7 @@
           <a:bodyPr wrap="square" lIns="0" tIns="0" rIns="0" bIns="0" rtlCol="0" anchor="ctr"/>
           <a:lstStyle/>
           <a:p>
-            <a:pPr marL="0" indent="0" algn="ctr">
-              <a:buNone/>
-            </a:pPr>
+            <a:pPr algn="ctr"/>
             <a:r>
               <a:rPr sz="1400" b="1" i="1">
                 <a:solidFill>
@@ -3334,11 +3579,11 @@
                 </a:solidFill>
                 <a:latin typeface="Calibri"/>
               </a:rPr>
-              <a:t>Illustration</a:t>
-            </a:r>
-            <a:endParaRPr lang="en-US" sz="1400" dirty="0"/>
-          </a:p>
-          <a:p>
+              <a:t>Bénéficiaires</a:t>
+            </a:r>
+          </a:p>
+          <a:p>
+            <a:pPr algn="ctr"/>
             <a:r>
               <a:rPr sz="1400" b="1" i="1">
                 <a:solidFill>
@@ -3346,7 +3591,7 @@
                 </a:solidFill>
                 <a:latin typeface="Calibri"/>
               </a:rPr>
-              <a:t>Carte + formulaire + rapport</a:t>
+              <a:t>Bénévoles · associations · collectivités</a:t>
             </a:r>
           </a:p>
         </p:txBody>
@@ -3386,7 +3631,7 @@
               </a:rPr>
               <a:t>4</a:t>
             </a:r>
-            <a:endParaRPr lang="en-US" sz="900" dirty="0"/>
+            <a:endParaRPr lang="en-US" sz="900"/>
           </a:p>
         </p:txBody>
       </p:sp>
@@ -3483,7 +3728,7 @@
               <a:buNone/>
             </a:pPr>
             <a:r>
-              <a:rPr lang="en-US" sz="900" dirty="0">
+              <a:rPr lang="en-US" sz="900">
                 <a:solidFill>
                   <a:srgbClr val="475569"/>
                 </a:solidFill>
@@ -3493,7 +3738,7 @@
               </a:rPr>
               <a:t>Pépite Sorbonne Université  ·  SNEE/D2E — Dossier de candidature</a:t>
             </a:r>
-            <a:endParaRPr lang="en-US" sz="900" dirty="0"/>
+            <a:endParaRPr lang="en-US" sz="900"/>
           </a:p>
         </p:txBody>
       </p:sp>
@@ -3586,18 +3831,15 @@
           <a:bodyPr wrap="square" lIns="0" tIns="0" rIns="0" bIns="0" rtlCol="0" anchor="ctr"/>
           <a:lstStyle/>
           <a:p>
-            <a:pPr marL="0" indent="0">
-              <a:buNone/>
-            </a:pPr>
-            <a:r>
-              <a:rPr sz="2800" b="1">
+            <a:r>
+              <a:rPr sz="2800" b="1" i="0">
                 <a:solidFill>
                   <a:srgbClr val="064E3B"/>
                 </a:solidFill>
-              </a:rPr>
-              <a:t>Comment ça marche ?</a:t>
-            </a:r>
-            <a:endParaRPr lang="en-US" sz="2800" dirty="0"/>
+                <a:latin typeface="Calibri"/>
+              </a:rPr>
+              <a:t>Démonstration du prototype</a:t>
+            </a:r>
           </a:p>
         </p:txBody>
       </p:sp>
@@ -3624,19 +3866,15 @@
           <a:bodyPr wrap="square" lIns="0" tIns="0" rIns="0" bIns="0" rtlCol="0" anchor="ctr"/>
           <a:lstStyle/>
           <a:p>
-            <a:pPr marL="0" indent="0">
-              <a:buNone/>
-            </a:pPr>
-            <a:r>
-              <a:rPr sz="1400" i="1">
-                <a:solidFill>
-                  <a:srgbClr val="475569"/>
-                </a:solidFill>
-                <a:latin typeface="Calibri"/>
-              </a:rPr>
-              <a:t>Le fonctionnement pratique de la solution, du terrain au rapport d’impact</a:t>
-            </a:r>
-            <a:endParaRPr lang="en-US" sz="1400" dirty="0"/>
+            <a:r>
+              <a:rPr sz="1400" b="0" i="1">
+                <a:solidFill>
+                  <a:srgbClr val="475569"/>
+                </a:solidFill>
+                <a:latin typeface="Calibri"/>
+              </a:rPr>
+              <a:t>Une boucle simple : signaler → agir → cartographier → valoriser</a:t>
+            </a:r>
           </a:p>
         </p:txBody>
       </p:sp>
@@ -3665,7 +3903,10 @@
         </p:spPr>
         <p:txBody>
           <a:bodyPr/>
-          <a:p/>
+          <a:lstStyle/>
+          <a:p>
+            <a:endParaRPr/>
+          </a:p>
         </p:txBody>
       </p:sp>
       <p:sp>
@@ -3691,19 +3932,15 @@
           <a:bodyPr wrap="square" lIns="0" tIns="0" rIns="0" bIns="0" rtlCol="0" anchor="ctr"/>
           <a:lstStyle/>
           <a:p>
-            <a:pPr marL="0" indent="0">
-              <a:buNone/>
-            </a:pPr>
-            <a:r>
-              <a:rPr sz="1500" b="1">
+            <a:r>
+              <a:rPr sz="1500" b="1" i="0">
                 <a:solidFill>
                   <a:srgbClr val="10B981"/>
                 </a:solidFill>
                 <a:latin typeface="Calibri"/>
               </a:rPr>
-              <a:t>Démonstration &amp; avancement</a:t>
-            </a:r>
-            <a:endParaRPr lang="en-US" sz="1500" dirty="0"/>
+              <a:t>Fonctionnement pratique</a:t>
+            </a:r>
           </a:p>
         </p:txBody>
       </p:sp>
@@ -3730,15 +3967,8 @@
           <a:bodyPr wrap="square" lIns="0" tIns="0" rIns="0" bIns="0" rtlCol="0" anchor="ctr"/>
           <a:lstStyle/>
           <a:p>
-            <a:pPr marL="342900" indent="-342900">
-              <a:spcAft>
-                <a:spcPts val="600"/>
-              </a:spcAft>
-              <a:buSzPct val="100000"/>
-              <a:buChar char="▸"/>
-            </a:pPr>
-            <a:r>
-              <a:rPr sz="1300">
+            <a:r>
+              <a:rPr sz="1250" b="0" i="0">
                 <a:solidFill>
                   <a:srgbClr val="475569"/>
                 </a:solidFill>
@@ -3746,11 +3976,10 @@
               </a:rPr>
               <a:t>Parcours bénévole :</a:t>
             </a:r>
-            <a:endParaRPr lang="en-US" sz="1300" dirty="0"/>
-          </a:p>
-          <a:p>
-            <a:r>
-              <a:rPr sz="1300">
+          </a:p>
+          <a:p>
+            <a:r>
+              <a:rPr sz="1250" b="0" i="0">
                 <a:solidFill>
                   <a:srgbClr val="475569"/>
                 </a:solidFill>
@@ -3761,57 +3990,47 @@
           </a:p>
           <a:p>
             <a:r>
-              <a:rPr sz="1300">
-                <a:solidFill>
-                  <a:srgbClr val="475569"/>
-                </a:solidFill>
-                <a:latin typeface="Calibri"/>
-              </a:rPr>
-              <a:t>2. Je signale un déchet, rejoins un formulaire ou déclare une action.</a:t>
-            </a:r>
-          </a:p>
-          <a:p>
-            <a:r>
-              <a:rPr sz="1300">
-                <a:solidFill>
-                  <a:srgbClr val="475569"/>
-                </a:solidFill>
-                <a:latin typeface="Calibri"/>
-              </a:rPr>
-              <a:t>3. Les données sont modérées, normalisées et visibles sur la carte.</a:t>
-            </a:r>
-          </a:p>
-          <a:p>
-            <a:r>
-              <a:rPr sz="1300">
-                <a:solidFill>
-                  <a:srgbClr val="475569"/>
-                </a:solidFill>
-                <a:latin typeface="Calibri"/>
-              </a:rPr>
-              <a:t>4. L’impact peut être consulté, exporté et présenté.</a:t>
-            </a:r>
-          </a:p>
-          <a:p>
-            <a:r>
-              <a:rPr sz="1300">
-                <a:solidFill>
-                  <a:srgbClr val="475569"/>
-                </a:solidFill>
-                <a:latin typeface="Calibri"/>
-              </a:rPr>
-              <a:t/>
-            </a:r>
-          </a:p>
-          <a:p>
-            <a:r>
-              <a:rPr sz="1300">
-                <a:solidFill>
-                  <a:srgbClr val="475569"/>
-                </a:solidFill>
-                <a:latin typeface="Calibri"/>
-              </a:rPr>
-              <a:t>État actuel : prototype web avancé, documentation structurée, architecture Supabase / Next.js / Clerk déjà en place.</a:t>
+              <a:rPr sz="1250" b="0" i="0">
+                <a:solidFill>
+                  <a:srgbClr val="475569"/>
+                </a:solidFill>
+                <a:latin typeface="Calibri"/>
+              </a:rPr>
+              <a:t>2. Je signale un besoin ou je déclare une action.</a:t>
+            </a:r>
+          </a:p>
+          <a:p>
+            <a:r>
+              <a:rPr sz="1250" b="0" i="0">
+                <a:solidFill>
+                  <a:srgbClr val="475569"/>
+                </a:solidFill>
+                <a:latin typeface="Calibri"/>
+              </a:rPr>
+              <a:t>3. Les données sont structurées, modérées puis visibles sur la carte.</a:t>
+            </a:r>
+          </a:p>
+          <a:p>
+            <a:r>
+              <a:rPr sz="1250" b="0" i="0">
+                <a:solidFill>
+                  <a:srgbClr val="475569"/>
+                </a:solidFill>
+                <a:latin typeface="Calibri"/>
+              </a:rPr>
+              <a:t>4. L’impact peut être consulté, partagé et exporté.</a:t>
+            </a:r>
+          </a:p>
+          <a:p/>
+          <a:p>
+            <a:r>
+              <a:rPr sz="1250" b="0" i="0">
+                <a:solidFill>
+                  <a:srgbClr val="475569"/>
+                </a:solidFill>
+                <a:latin typeface="Calibri"/>
+              </a:rPr>
+              <a:t>État actuel : prototype web avancé avec carte, formulaires, profils, rapports et documentation structurée.</a:t>
             </a:r>
           </a:p>
         </p:txBody>
@@ -3841,7 +4060,10 @@
         </p:spPr>
         <p:txBody>
           <a:bodyPr/>
-          <a:p/>
+          <a:lstStyle/>
+          <a:p>
+            <a:endParaRPr/>
+          </a:p>
         </p:txBody>
       </p:sp>
       <p:sp>
@@ -3867,9 +4089,7 @@
           <a:bodyPr wrap="square" lIns="0" tIns="0" rIns="0" bIns="0" rtlCol="0" anchor="ctr"/>
           <a:lstStyle/>
           <a:p>
-            <a:pPr marL="0" indent="0" algn="ctr">
-              <a:buNone/>
-            </a:pPr>
+            <a:pPr algn="ctr"/>
             <a:r>
               <a:rPr sz="1400" b="1" i="1">
                 <a:solidFill>
@@ -3879,9 +4099,9 @@
               </a:rPr>
               <a:t>Capture prototype</a:t>
             </a:r>
-            <a:endParaRPr lang="en-US" sz="1400" dirty="0"/>
-          </a:p>
-          <a:p>
+          </a:p>
+          <a:p>
+            <a:pPr algn="ctr"/>
             <a:r>
               <a:rPr sz="1400" b="1" i="1">
                 <a:solidFill>
@@ -3889,7 +4109,7 @@
                 </a:solidFill>
                 <a:latin typeface="Calibri"/>
               </a:rPr>
-              <a:t>Carte / formulaire / rapport</a:t>
+              <a:t>Carte / formulaire / rapport d’impact</a:t>
             </a:r>
           </a:p>
         </p:txBody>
@@ -3921,7 +4141,7 @@
               <a:buNone/>
             </a:pPr>
             <a:r>
-              <a:rPr lang="en-US" sz="900" dirty="0">
+              <a:rPr lang="en-US" sz="900">
                 <a:solidFill>
                   <a:srgbClr val="475569"/>
                 </a:solidFill>
@@ -3931,7 +4151,7 @@
               </a:rPr>
               <a:t>Pépite Sorbonne Université  ·  D2E — Dossier de candidature</a:t>
             </a:r>
-            <a:endParaRPr lang="en-US" sz="900" dirty="0"/>
+            <a:endParaRPr lang="en-US" sz="900"/>
           </a:p>
         </p:txBody>
       </p:sp>
@@ -3970,7 +4190,7 @@
               </a:rPr>
               <a:t>5</a:t>
             </a:r>
-            <a:endParaRPr lang="en-US" sz="900" dirty="0"/>
+            <a:endParaRPr lang="en-US" sz="900"/>
           </a:p>
         </p:txBody>
       </p:sp>
@@ -4129,22 +4349,15 @@
           <a:bodyPr wrap="square" lIns="0" tIns="0" rIns="0" bIns="0" rtlCol="0" anchor="ctr"/>
           <a:lstStyle/>
           <a:p>
-            <a:pPr marL="0" indent="0">
-              <a:buNone/>
-            </a:pPr>
-            <a:r>
-              <a:rPr sz="2800" b="1">
+            <a:r>
+              <a:rPr sz="2800" b="1" i="0">
                 <a:solidFill>
                   <a:srgbClr val="064E3B"/>
                 </a:solidFill>
                 <a:latin typeface="Calibri"/>
               </a:rPr>
-              <a:t>Concurrence et avantages concurrentiels</a:t>
-            </a:r>
-            <a:endParaRPr lang="en-US" sz="2800" dirty="0">
-              <a:latin typeface="Calibri" panose="020F0502020204030204" pitchFamily="34" charset="0"/>
-              <a:cs typeface="Calibri" panose="020F0502020204030204" pitchFamily="34" charset="0"/>
-            </a:endParaRPr>
+              <a:t>Ce que j’ai déjà réalisé</a:t>
+            </a:r>
           </a:p>
         </p:txBody>
       </p:sp>
@@ -4171,19 +4384,15 @@
           <a:bodyPr wrap="square" lIns="0" tIns="0" rIns="0" bIns="0" rtlCol="0" anchor="ctr"/>
           <a:lstStyle/>
           <a:p>
-            <a:pPr marL="0" indent="0">
-              <a:buNone/>
-            </a:pPr>
-            <a:r>
-              <a:rPr sz="1400" i="1">
-                <a:solidFill>
-                  <a:srgbClr val="475569"/>
-                </a:solidFill>
-                <a:latin typeface="Calibri"/>
-              </a:rPr>
-              <a:t>Un positionnement complémentaire : structurer la donnée et la preuve terrain</a:t>
-            </a:r>
-            <a:endParaRPr lang="en-US" sz="1400" dirty="0"/>
+            <a:r>
+              <a:rPr sz="1400" b="0" i="1">
+                <a:solidFill>
+                  <a:srgbClr val="475569"/>
+                </a:solidFill>
+                <a:latin typeface="Calibri"/>
+              </a:rPr>
+              <a:t>Des démarches concrètes pour prouver que le projet dépasse le stade de l’idée</a:t>
+            </a:r>
           </a:p>
         </p:txBody>
       </p:sp>
@@ -4212,7 +4421,10 @@
         </p:spPr>
         <p:txBody>
           <a:bodyPr/>
-          <a:p/>
+          <a:lstStyle/>
+          <a:p>
+            <a:endParaRPr/>
+          </a:p>
         </p:txBody>
       </p:sp>
       <p:sp>
@@ -4238,19 +4450,15 @@
           <a:bodyPr wrap="square" lIns="0" tIns="0" rIns="0" bIns="0" rtlCol="0" anchor="ctr"/>
           <a:lstStyle/>
           <a:p>
-            <a:pPr marL="0" indent="0">
-              <a:buNone/>
-            </a:pPr>
-            <a:r>
-              <a:rPr sz="1500" b="1">
+            <a:r>
+              <a:rPr sz="1500" b="1" i="0">
                 <a:solidFill>
                   <a:srgbClr val="10B981"/>
                 </a:solidFill>
                 <a:latin typeface="Calibri"/>
               </a:rPr>
-              <a:t>Comparaison rapide</a:t>
-            </a:r>
-            <a:endParaRPr lang="en-US" sz="1500" dirty="0"/>
+              <a:t>Preuves d’avancement</a:t>
+            </a:r>
           </a:p>
         </p:txBody>
       </p:sp>
@@ -4277,121 +4485,81 @@
           <a:bodyPr wrap="square" lIns="0" tIns="0" rIns="0" bIns="0" rtlCol="0" anchor="ctr"/>
           <a:lstStyle/>
           <a:p>
-            <a:pPr marL="342900" indent="-342900">
-              <a:spcAft>
-                <a:spcPts val="600"/>
-              </a:spcAft>
-              <a:buSzPct val="100000"/>
-              <a:buChar char="▸"/>
-            </a:pPr>
-            <a:r>
-              <a:rPr sz="1300">
-                <a:solidFill>
-                  <a:srgbClr val="475569"/>
-                </a:solidFill>
-                <a:latin typeface="Calibri"/>
-              </a:rPr>
-              <a:t>Références ou alternatives :</a:t>
-            </a:r>
-            <a:endParaRPr lang="en-US" sz="1300" dirty="0"/>
-          </a:p>
-          <a:p>
-            <a:r>
-              <a:rPr sz="1300">
-                <a:solidFill>
-                  <a:srgbClr val="475569"/>
-                </a:solidFill>
-                <a:latin typeface="Calibri"/>
-              </a:rPr>
-              <a:t>• cartes de signalement existantes ;</a:t>
-            </a:r>
-          </a:p>
-          <a:p>
-            <a:r>
-              <a:rPr sz="1300">
-                <a:solidFill>
-                  <a:srgbClr val="475569"/>
-                </a:solidFill>
-                <a:latin typeface="Calibri"/>
-              </a:rPr>
-              <a:t>• formulaires Google Sheets associatifs ;</a:t>
-            </a:r>
-          </a:p>
-          <a:p>
-            <a:r>
-              <a:rPr sz="1300">
-                <a:solidFill>
-                  <a:srgbClr val="475569"/>
-                </a:solidFill>
-                <a:latin typeface="Calibri"/>
-              </a:rPr>
-              <a:t>• outils internes de collectivités ;</a:t>
-            </a:r>
-          </a:p>
-          <a:p>
-            <a:r>
-              <a:rPr sz="1300">
-                <a:solidFill>
-                  <a:srgbClr val="475569"/>
-                </a:solidFill>
-                <a:latin typeface="Calibri"/>
-              </a:rPr>
-              <a:t>• plateformes de mobilisation ponctuelle.</a:t>
-            </a:r>
-          </a:p>
-          <a:p>
-            <a:r>
-              <a:rPr sz="1300">
-                <a:solidFill>
-                  <a:srgbClr val="475569"/>
-                </a:solidFill>
-                <a:latin typeface="Calibri"/>
-              </a:rPr>
-              <a:t/>
-            </a:r>
-          </a:p>
-          <a:p>
-            <a:r>
-              <a:rPr sz="1300">
-                <a:solidFill>
-                  <a:srgbClr val="475569"/>
-                </a:solidFill>
-                <a:latin typeface="Calibri"/>
-              </a:rPr>
-              <a:t>Différenciation CleanMyMap :</a:t>
-            </a:r>
-          </a:p>
-          <a:p>
-            <a:r>
-              <a:rPr sz="1300">
-                <a:solidFill>
-                  <a:srgbClr val="475569"/>
-                </a:solidFill>
-                <a:latin typeface="Calibri"/>
-              </a:rPr>
-              <a:t>• boucle complète signalement → action → impact ;</a:t>
-            </a:r>
-          </a:p>
-          <a:p>
-            <a:r>
-              <a:rPr sz="1300">
-                <a:solidFill>
-                  <a:srgbClr val="475569"/>
-                </a:solidFill>
-                <a:latin typeface="Calibri"/>
-              </a:rPr>
-              <a:t>• données cartographiques et rapports exploitables ;</a:t>
-            </a:r>
-          </a:p>
-          <a:p>
-            <a:r>
-              <a:rPr sz="1300">
-                <a:solidFill>
-                  <a:srgbClr val="475569"/>
-                </a:solidFill>
-                <a:latin typeface="Calibri"/>
-              </a:rPr>
-              <a:t>• approche bénévole, open source et compatible partenariats.</a:t>
+            <a:r>
+              <a:rPr sz="1250" b="0" i="0">
+                <a:solidFill>
+                  <a:srgbClr val="475569"/>
+                </a:solidFill>
+                <a:latin typeface="Calibri"/>
+              </a:rPr>
+              <a:t>Travail déjà engagé :</a:t>
+            </a:r>
+          </a:p>
+          <a:p>
+            <a:r>
+              <a:rPr sz="1250" b="0" i="0">
+                <a:solidFill>
+                  <a:srgbClr val="475569"/>
+                </a:solidFill>
+                <a:latin typeface="Calibri"/>
+              </a:rPr>
+              <a:t>• prototype web fonctionnel ;</a:t>
+            </a:r>
+          </a:p>
+          <a:p>
+            <a:r>
+              <a:rPr sz="1250" b="0" i="0">
+                <a:solidFill>
+                  <a:srgbClr val="475569"/>
+                </a:solidFill>
+                <a:latin typeface="Calibri"/>
+              </a:rPr>
+              <a:t>• carte, formulaires, profils, rapports ;</a:t>
+            </a:r>
+          </a:p>
+          <a:p>
+            <a:r>
+              <a:rPr sz="1250" b="0" i="0">
+                <a:solidFill>
+                  <a:srgbClr val="475569"/>
+                </a:solidFill>
+                <a:latin typeface="Calibri"/>
+              </a:rPr>
+              <a:t>• documentation et architecture structurées ;</a:t>
+            </a:r>
+          </a:p>
+          <a:p>
+            <a:r>
+              <a:rPr sz="1250" b="0" i="0">
+                <a:solidFill>
+                  <a:srgbClr val="475569"/>
+                </a:solidFill>
+                <a:latin typeface="Calibri"/>
+              </a:rPr>
+              <a:t>• réflexion sur données, modération et indicateurs ;</a:t>
+            </a:r>
+          </a:p>
+          <a:p>
+            <a:r>
+              <a:rPr sz="1250" b="0" i="0">
+                <a:solidFill>
+                  <a:srgbClr val="475569"/>
+                </a:solidFill>
+                <a:latin typeface="Calibri"/>
+              </a:rPr>
+              <a:t>• premiers contacts avec des acteurs de la dépollution et de la sensibilisation.</a:t>
+            </a:r>
+          </a:p>
+          <a:p/>
+          <a:p>
+            <a:r>
+              <a:rPr sz="1250" b="0" i="0">
+                <a:solidFill>
+                  <a:srgbClr val="475569"/>
+                </a:solidFill>
+                <a:latin typeface="Calibri"/>
+              </a:rPr>
+              <a:t>Prochaine étape : tester sur le terrain et prioriser les usages les plus utiles.</a:t>
             </a:r>
           </a:p>
         </p:txBody>
@@ -4421,7 +4589,10 @@
         </p:spPr>
         <p:txBody>
           <a:bodyPr/>
-          <a:p/>
+          <a:lstStyle/>
+          <a:p>
+            <a:endParaRPr/>
+          </a:p>
         </p:txBody>
       </p:sp>
       <p:sp>
@@ -4447,9 +4618,7 @@
           <a:bodyPr wrap="square" lIns="0" tIns="0" rIns="0" bIns="0" rtlCol="0" anchor="ctr"/>
           <a:lstStyle/>
           <a:p>
-            <a:pPr marL="0" indent="0" algn="ctr">
-              <a:buNone/>
-            </a:pPr>
+            <a:pPr algn="ctr"/>
             <a:r>
               <a:rPr sz="1400" b="1" i="1">
                 <a:solidFill>
@@ -4457,11 +4626,11 @@
                 </a:solidFill>
                 <a:latin typeface="Calibri"/>
               </a:rPr>
-              <a:t>Tableau à compléter</a:t>
-            </a:r>
-            <a:endParaRPr lang="en-US" sz="1400" dirty="0"/>
-          </a:p>
-          <a:p>
+              <a:t>Preuves à montrer</a:t>
+            </a:r>
+          </a:p>
+          <a:p>
+            <a:pPr algn="ctr"/>
             <a:r>
               <a:rPr sz="1400" b="1" i="1">
                 <a:solidFill>
@@ -4469,7 +4638,7 @@
                 </a:solidFill>
                 <a:latin typeface="Calibri"/>
               </a:rPr>
-              <a:t>Signalement · carte · impact · export</a:t>
+              <a:t>Prototype · documentation · échanges terrain</a:t>
             </a:r>
           </a:p>
         </p:txBody>
@@ -4509,7 +4678,7 @@
               </a:rPr>
               <a:t>6</a:t>
             </a:r>
-            <a:endParaRPr lang="en-US" sz="900" dirty="0"/>
+            <a:endParaRPr lang="en-US" sz="900"/>
           </a:p>
         </p:txBody>
       </p:sp>
@@ -4606,7 +4775,7 @@
               <a:buNone/>
             </a:pPr>
             <a:r>
-              <a:rPr lang="en-US" sz="900" dirty="0">
+              <a:rPr lang="en-US" sz="900">
                 <a:solidFill>
                   <a:srgbClr val="475569"/>
                 </a:solidFill>
@@ -4616,7 +4785,7 @@
               </a:rPr>
               <a:t>Pépite Sorbonne Université  ·  SNEE/D2E — Dossier de candidature</a:t>
             </a:r>
-            <a:endParaRPr lang="en-US" sz="900" dirty="0"/>
+            <a:endParaRPr lang="en-US" sz="900"/>
           </a:p>
         </p:txBody>
       </p:sp>
@@ -4709,22 +4878,15 @@
           <a:bodyPr wrap="square" lIns="0" tIns="0" rIns="0" bIns="0" rtlCol="0" anchor="ctr"/>
           <a:lstStyle/>
           <a:p>
-            <a:pPr marL="0" indent="0">
-              <a:buNone/>
-            </a:pPr>
-            <a:r>
-              <a:rPr sz="2800" b="1">
+            <a:r>
+              <a:rPr sz="2800" b="1" i="0">
                 <a:solidFill>
                   <a:srgbClr val="064E3B"/>
                 </a:solidFill>
                 <a:latin typeface="Calibri"/>
               </a:rPr>
-              <a:t>Roadmap</a:t>
-            </a:r>
-            <a:endParaRPr lang="en-US" sz="2800" dirty="0">
-              <a:latin typeface="Calibri" panose="020F0502020204030204" pitchFamily="34" charset="0"/>
-              <a:cs typeface="Calibri" panose="020F0502020204030204" pitchFamily="34" charset="0"/>
-            </a:endParaRPr>
+              <a:t>Ce qu’il reste à construire</a:t>
+            </a:r>
           </a:p>
         </p:txBody>
       </p:sp>
@@ -4751,19 +4913,15 @@
           <a:bodyPr wrap="square" lIns="0" tIns="0" rIns="0" bIns="0" rtlCol="0" anchor="ctr"/>
           <a:lstStyle/>
           <a:p>
-            <a:pPr marL="0" indent="0">
-              <a:buNone/>
-            </a:pPr>
-            <a:r>
-              <a:rPr sz="1400" i="1">
-                <a:solidFill>
-                  <a:srgbClr val="475569"/>
-                </a:solidFill>
-                <a:latin typeface="Calibri"/>
-              </a:rPr>
-              <a:t>Ce qui existe déjà, puis les chantiers prioritaires de l’année</a:t>
-            </a:r>
-            <a:endParaRPr lang="en-US" sz="1400" dirty="0"/>
+            <a:r>
+              <a:rPr sz="1400" b="0" i="1">
+                <a:solidFill>
+                  <a:srgbClr val="475569"/>
+                </a:solidFill>
+                <a:latin typeface="Calibri"/>
+              </a:rPr>
+              <a:t>Passer d’un prototype fonctionnel à un projet associatif testable sur le terrain</a:t>
+            </a:r>
           </a:p>
         </p:txBody>
       </p:sp>
@@ -4792,7 +4950,10 @@
         </p:spPr>
         <p:txBody>
           <a:bodyPr/>
-          <a:p/>
+          <a:lstStyle/>
+          <a:p>
+            <a:endParaRPr/>
+          </a:p>
         </p:txBody>
       </p:sp>
       <p:sp>
@@ -4818,7 +4979,10 @@
         </p:spPr>
         <p:txBody>
           <a:bodyPr/>
-          <a:p/>
+          <a:lstStyle/>
+          <a:p>
+            <a:endParaRPr/>
+          </a:p>
         </p:txBody>
       </p:sp>
       <p:sp>
@@ -4856,7 +5020,7 @@
               </a:rPr>
               <a:t>1</a:t>
             </a:r>
-            <a:endParaRPr lang="en-US" sz="2200" dirty="0"/>
+            <a:endParaRPr lang="en-US" sz="2200"/>
           </a:p>
         </p:txBody>
       </p:sp>
@@ -4884,15 +5048,14 @@
           <a:lstStyle/>
           <a:p>
             <a:r>
-              <a:rPr sz="1700" b="1">
+              <a:rPr sz="1700" b="1" i="0">
                 <a:solidFill>
                   <a:srgbClr val="064E3B"/>
                 </a:solidFill>
                 <a:latin typeface="Calibri"/>
               </a:rPr>
-              <a:t>Actions déjà réalisées</a:t>
-            </a:r>
-            <a:endParaRPr lang="en-US" sz="1700" dirty="0"/>
+              <a:t>Valider le terrain</a:t>
+            </a:r>
           </a:p>
         </p:txBody>
       </p:sp>
@@ -4919,51 +5082,47 @@
           <a:bodyPr wrap="square" lIns="0" tIns="0" rIns="0" bIns="0" rtlCol="0" anchor="ctr"/>
           <a:lstStyle/>
           <a:p>
-            <a:pPr marL="0" indent="0">
-              <a:buNone/>
-            </a:pPr>
-            <a:r>
-              <a:rPr sz="1300" i="1">
-                <a:solidFill>
-                  <a:srgbClr val="475569"/>
-                </a:solidFill>
-                <a:latin typeface="Calibri"/>
-              </a:rPr>
-              <a:t>• Prototype web fonctionnel</a:t>
-            </a:r>
-            <a:endParaRPr lang="en-US" sz="1300" dirty="0"/>
-          </a:p>
-          <a:p>
-            <a:r>
-              <a:rPr sz="1300" i="1">
-                <a:solidFill>
-                  <a:srgbClr val="475569"/>
-                </a:solidFill>
-                <a:latin typeface="Calibri"/>
-              </a:rPr>
-              <a:t>• Carte, formulaires, rapports, profils</a:t>
-            </a:r>
-          </a:p>
-          <a:p>
-            <a:r>
-              <a:rPr sz="1300" i="1">
-                <a:solidFill>
-                  <a:srgbClr val="475569"/>
-                </a:solidFill>
-                <a:latin typeface="Calibri"/>
-              </a:rPr>
-              <a:t>• Documentation projet structurée</a:t>
-            </a:r>
-          </a:p>
-          <a:p>
-            <a:r>
-              <a:rPr sz="1300" i="1">
-                <a:solidFill>
-                  <a:srgbClr val="475569"/>
-                </a:solidFill>
-                <a:latin typeface="Calibri"/>
-              </a:rPr>
-              <a:t>• Premiers contacts et pistes partenaires</a:t>
+            <a:r>
+              <a:rPr sz="1150" b="0" i="1">
+                <a:solidFill>
+                  <a:srgbClr val="475569"/>
+                </a:solidFill>
+                <a:latin typeface="Calibri"/>
+              </a:rPr>
+              <a:t>• Tests bénévoles et associations</a:t>
+            </a:r>
+          </a:p>
+          <a:p>
+            <a:r>
+              <a:rPr sz="1150" b="0" i="1">
+                <a:solidFill>
+                  <a:srgbClr val="475569"/>
+                </a:solidFill>
+                <a:latin typeface="Calibri"/>
+              </a:rPr>
+              <a:t>• Observation des usages réels</a:t>
+            </a:r>
+          </a:p>
+          <a:p>
+            <a:r>
+              <a:rPr sz="1150" b="0" i="1">
+                <a:solidFill>
+                  <a:srgbClr val="475569"/>
+                </a:solidFill>
+                <a:latin typeface="Calibri"/>
+              </a:rPr>
+              <a:t>• Parcours prioritaires</a:t>
+            </a:r>
+          </a:p>
+          <a:p>
+            <a:r>
+              <a:rPr sz="1150" b="0" i="1">
+                <a:solidFill>
+                  <a:srgbClr val="475569"/>
+                </a:solidFill>
+                <a:latin typeface="Calibri"/>
+              </a:rPr>
+              <a:t>• Valeur réellement créée</a:t>
             </a:r>
           </a:p>
         </p:txBody>
@@ -4993,7 +5152,10 @@
         </p:spPr>
         <p:txBody>
           <a:bodyPr/>
-          <a:p/>
+          <a:lstStyle/>
+          <a:p>
+            <a:endParaRPr/>
+          </a:p>
         </p:txBody>
       </p:sp>
       <p:sp>
@@ -5019,7 +5181,10 @@
         </p:spPr>
         <p:txBody>
           <a:bodyPr/>
-          <a:p/>
+          <a:lstStyle/>
+          <a:p>
+            <a:endParaRPr/>
+          </a:p>
         </p:txBody>
       </p:sp>
       <p:sp>
@@ -5057,7 +5222,7 @@
               </a:rPr>
               <a:t>2</a:t>
             </a:r>
-            <a:endParaRPr lang="en-US" sz="2200" dirty="0"/>
+            <a:endParaRPr lang="en-US" sz="2200"/>
           </a:p>
         </p:txBody>
       </p:sp>
@@ -5085,15 +5250,14 @@
           <a:lstStyle/>
           <a:p>
             <a:r>
-              <a:rPr sz="1700" b="1">
+              <a:rPr sz="1700" b="1" i="0">
                 <a:solidFill>
                   <a:srgbClr val="064E3B"/>
                 </a:solidFill>
                 <a:latin typeface="Calibri"/>
               </a:rPr>
-              <a:t>Chantiers prioritaires</a:t>
-            </a:r>
-            <a:endParaRPr lang="en-US" sz="1700" dirty="0"/>
+              <a:t>Structurer l’association</a:t>
+            </a:r>
           </a:p>
         </p:txBody>
       </p:sp>
@@ -5121,47 +5285,46 @@
           <a:lstStyle/>
           <a:p>
             <a:r>
-              <a:rPr sz="1300" i="1">
-                <a:solidFill>
-                  <a:srgbClr val="475569"/>
-                </a:solidFill>
-                <a:latin typeface="Calibri"/>
-              </a:rPr>
-              <a:t>• Tests utilisateurs terrain</a:t>
-            </a:r>
-            <a:endParaRPr lang="en-US" sz="1300" dirty="0"/>
-          </a:p>
-          <a:p>
-            <a:r>
-              <a:rPr sz="1300" i="1">
-                <a:solidFill>
-                  <a:srgbClr val="475569"/>
-                </a:solidFill>
-                <a:latin typeface="Calibri"/>
-              </a:rPr>
-              <a:t>• Simplification des parcours clés</a:t>
-            </a:r>
-          </a:p>
-          <a:p>
-            <a:r>
-              <a:rPr sz="1300" i="1">
-                <a:solidFill>
-                  <a:srgbClr val="475569"/>
-                </a:solidFill>
-                <a:latin typeface="Calibri"/>
-              </a:rPr>
-              <a:t>• Cadrage des données et de la modération</a:t>
-            </a:r>
-          </a:p>
-          <a:p>
-            <a:r>
-              <a:rPr sz="1300" i="1">
-                <a:solidFill>
-                  <a:srgbClr val="475569"/>
-                </a:solidFill>
-                <a:latin typeface="Calibri"/>
-              </a:rPr>
-              <a:t>• Modèle de partenariat soutenable</a:t>
+              <a:rPr sz="1150" b="0" i="1">
+                <a:solidFill>
+                  <a:srgbClr val="475569"/>
+                </a:solidFill>
+                <a:latin typeface="Calibri"/>
+              </a:rPr>
+              <a:t>• Gouvernance et rôles</a:t>
+            </a:r>
+          </a:p>
+          <a:p>
+            <a:r>
+              <a:rPr sz="1150" b="0" i="1">
+                <a:solidFill>
+                  <a:srgbClr val="475569"/>
+                </a:solidFill>
+                <a:latin typeface="Calibri"/>
+              </a:rPr>
+              <a:t>• Données et modération</a:t>
+            </a:r>
+          </a:p>
+          <a:p>
+            <a:r>
+              <a:rPr sz="1150" b="0" i="1">
+                <a:solidFill>
+                  <a:srgbClr val="475569"/>
+                </a:solidFill>
+                <a:latin typeface="Calibri"/>
+              </a:rPr>
+              <a:t>• Place des bénévoles</a:t>
+            </a:r>
+          </a:p>
+          <a:p>
+            <a:r>
+              <a:rPr sz="1150" b="0" i="1">
+                <a:solidFill>
+                  <a:srgbClr val="475569"/>
+                </a:solidFill>
+                <a:latin typeface="Calibri"/>
+              </a:rPr>
+              <a:t>• Modèle soutenable</a:t>
             </a:r>
           </a:p>
         </p:txBody>
@@ -5191,7 +5354,10 @@
         </p:spPr>
         <p:txBody>
           <a:bodyPr/>
-          <a:p/>
+          <a:lstStyle/>
+          <a:p>
+            <a:endParaRPr/>
+          </a:p>
         </p:txBody>
       </p:sp>
       <p:sp>
@@ -5217,7 +5383,10 @@
         </p:spPr>
         <p:txBody>
           <a:bodyPr/>
-          <a:p/>
+          <a:lstStyle/>
+          <a:p>
+            <a:endParaRPr/>
+          </a:p>
         </p:txBody>
       </p:sp>
       <p:sp>
@@ -5255,7 +5424,7 @@
               </a:rPr>
               <a:t>3</a:t>
             </a:r>
-            <a:endParaRPr lang="en-US" sz="2200" dirty="0"/>
+            <a:endParaRPr lang="en-US" sz="2200"/>
           </a:p>
         </p:txBody>
       </p:sp>
@@ -5282,19 +5451,15 @@
           <a:bodyPr wrap="square" lIns="0" tIns="0" rIns="0" bIns="0" rtlCol="0" anchor="ctr"/>
           <a:lstStyle/>
           <a:p>
-            <a:pPr marL="0" indent="0">
-              <a:buNone/>
-            </a:pPr>
-            <a:r>
-              <a:rPr sz="1700" b="1">
+            <a:r>
+              <a:rPr sz="1700" b="1" i="0">
                 <a:solidFill>
                   <a:srgbClr val="064E3B"/>
                 </a:solidFill>
                 <a:latin typeface="Calibri"/>
               </a:rPr>
-              <a:t>Perspectives</a:t>
-            </a:r>
-            <a:endParaRPr lang="en-US" sz="1700" dirty="0"/>
+              <a:t>Déployer utilement</a:t>
+            </a:r>
           </a:p>
         </p:txBody>
       </p:sp>
@@ -5322,47 +5487,46 @@
           <a:lstStyle/>
           <a:p>
             <a:r>
-              <a:rPr sz="1300" i="1">
-                <a:solidFill>
-                  <a:srgbClr val="475569"/>
-                </a:solidFill>
-                <a:latin typeface="Calibri"/>
-              </a:rPr>
-              <a:t>• Déploiement pilote local</a:t>
-            </a:r>
-            <a:endParaRPr lang="en-US" sz="1300" dirty="0"/>
-          </a:p>
-          <a:p>
-            <a:r>
-              <a:rPr sz="1300" i="1">
-                <a:solidFill>
-                  <a:srgbClr val="475569"/>
-                </a:solidFill>
-                <a:latin typeface="Calibri"/>
-              </a:rPr>
-              <a:t>• Collaboration associative / académique</a:t>
-            </a:r>
-          </a:p>
-          <a:p>
-            <a:r>
-              <a:rPr sz="1300" i="1">
-                <a:solidFill>
-                  <a:srgbClr val="475569"/>
-                </a:solidFill>
-                <a:latin typeface="Calibri"/>
-              </a:rPr>
-              <a:t>• Rapports d’impact réutilisables</a:t>
-            </a:r>
-          </a:p>
-          <a:p>
-            <a:r>
-              <a:rPr sz="1300" i="1">
-                <a:solidFill>
-                  <a:srgbClr val="475569"/>
-                </a:solidFill>
-                <a:latin typeface="Calibri"/>
-              </a:rPr>
-              <a:t>• Base de données terrain plus fiable</a:t>
+              <a:rPr sz="1150" b="0" i="1">
+                <a:solidFill>
+                  <a:srgbClr val="475569"/>
+                </a:solidFill>
+                <a:latin typeface="Calibri"/>
+              </a:rPr>
+              <a:t>• Pilote local</a:t>
+            </a:r>
+          </a:p>
+          <a:p>
+            <a:r>
+              <a:rPr sz="1150" b="0" i="1">
+                <a:solidFill>
+                  <a:srgbClr val="475569"/>
+                </a:solidFill>
+                <a:latin typeface="Calibri"/>
+              </a:rPr>
+              <a:t>• Partenariats consolidés</a:t>
+            </a:r>
+          </a:p>
+          <a:p>
+            <a:r>
+              <a:rPr sz="1150" b="0" i="1">
+                <a:solidFill>
+                  <a:srgbClr val="475569"/>
+                </a:solidFill>
+                <a:latin typeface="Calibri"/>
+              </a:rPr>
+              <a:t>• Rapports simples</a:t>
+            </a:r>
+          </a:p>
+          <a:p>
+            <a:r>
+              <a:rPr sz="1150" b="0" i="1">
+                <a:solidFill>
+                  <a:srgbClr val="475569"/>
+                </a:solidFill>
+                <a:latin typeface="Calibri"/>
+              </a:rPr>
+              <a:t>• Contributions valorisées</a:t>
             </a:r>
           </a:p>
         </p:txBody>
@@ -5402,7 +5566,7 @@
               </a:rPr>
               <a:t>7</a:t>
             </a:r>
-            <a:endParaRPr lang="en-US" sz="900" dirty="0"/>
+            <a:endParaRPr lang="en-US" sz="900"/>
           </a:p>
         </p:txBody>
       </p:sp>
@@ -5499,7 +5663,7 @@
               <a:buNone/>
             </a:pPr>
             <a:r>
-              <a:rPr lang="en-US" sz="900" dirty="0">
+              <a:rPr lang="en-US" sz="900">
                 <a:solidFill>
                   <a:srgbClr val="475569"/>
                 </a:solidFill>
@@ -5509,7 +5673,7 @@
               </a:rPr>
               <a:t>Pépite Sorbonne Université  ·  SNEE/D2E — Dossier de candidature</a:t>
             </a:r>
-            <a:endParaRPr lang="en-US" sz="900" dirty="0"/>
+            <a:endParaRPr lang="en-US" sz="900"/>
           </a:p>
         </p:txBody>
       </p:sp>
@@ -5595,18 +5759,14 @@
           <a:lstStyle/>
           <a:p>
             <a:r>
-              <a:rPr sz="2800" b="1">
+              <a:rPr sz="2800" b="1" i="0">
                 <a:solidFill>
                   <a:srgbClr val="064E3B"/>
                 </a:solidFill>
                 <a:latin typeface="Calibri"/>
               </a:rPr>
-              <a:t>Apports de Pépite Sorbonne Université</a:t>
-            </a:r>
-            <a:endParaRPr lang="en-US" sz="2800" dirty="0">
-              <a:latin typeface="Calibri" panose="020F0502020204030204" pitchFamily="34" charset="0"/>
-              <a:cs typeface="Calibri" panose="020F0502020204030204" pitchFamily="34" charset="0"/>
-            </a:endParaRPr>
+              <a:t>Pourquoi Pépite ?</a:t>
+            </a:r>
           </a:p>
         </p:txBody>
       </p:sp>
@@ -5634,15 +5794,14 @@
           <a:lstStyle/>
           <a:p>
             <a:r>
-              <a:rPr sz="1400" i="1">
-                <a:solidFill>
-                  <a:srgbClr val="475569"/>
-                </a:solidFill>
-                <a:latin typeface="Calibri"/>
-              </a:rPr>
-              <a:t>Passer d’un prototype étudiant à un projet testable, cadré et crédible</a:t>
-            </a:r>
-            <a:endParaRPr lang="en-US" sz="1400" dirty="0"/>
+              <a:rPr sz="1400" b="0" i="1">
+                <a:solidFill>
+                  <a:srgbClr val="475569"/>
+                </a:solidFill>
+                <a:latin typeface="Calibri"/>
+              </a:rPr>
+              <a:t>Être accompagné pour transformer un prototype associatif en projet fiable et durable</a:t>
+            </a:r>
           </a:p>
         </p:txBody>
       </p:sp>
@@ -5671,7 +5830,10 @@
         </p:spPr>
         <p:txBody>
           <a:bodyPr/>
-          <a:p/>
+          <a:lstStyle/>
+          <a:p>
+            <a:endParaRPr/>
+          </a:p>
         </p:txBody>
       </p:sp>
       <p:sp>
@@ -5697,19 +5859,15 @@
           <a:bodyPr wrap="square" lIns="0" tIns="0" rIns="0" bIns="0" rtlCol="0" anchor="ctr"/>
           <a:lstStyle/>
           <a:p>
-            <a:pPr marL="0" indent="0">
-              <a:buNone/>
-            </a:pPr>
-            <a:r>
-              <a:rPr sz="1500" b="1">
+            <a:r>
+              <a:rPr sz="1500" b="1" i="0">
                 <a:solidFill>
                   <a:srgbClr val="10B981"/>
                 </a:solidFill>
                 <a:latin typeface="Calibri"/>
               </a:rPr>
-              <a:t>Besoins prioritaires</a:t>
-            </a:r>
-            <a:endParaRPr lang="en-US" sz="1500" dirty="0"/>
+              <a:t>Apports attendus</a:t>
+            </a:r>
           </a:p>
         </p:txBody>
       </p:sp>
@@ -5736,87 +5894,81 @@
           <a:bodyPr wrap="square" lIns="0" tIns="0" rIns="0" bIns="0" rtlCol="0" anchor="ctr"/>
           <a:lstStyle/>
           <a:p>
-            <a:pPr marL="342900" indent="-342900">
-              <a:spcAft>
-                <a:spcPts val="600"/>
-              </a:spcAft>
-              <a:buSzPct val="100000"/>
-              <a:buChar char="▸"/>
-            </a:pPr>
-            <a:r>
-              <a:rPr sz="1300">
-                <a:solidFill>
-                  <a:srgbClr val="475569"/>
-                </a:solidFill>
-                <a:latin typeface="Calibri"/>
-              </a:rPr>
-              <a:t>Pépite peut aider CleanMyMap à avancer sur quatre points :</a:t>
-            </a:r>
-          </a:p>
-          <a:p>
-            <a:r>
-              <a:rPr sz="1300">
-                <a:solidFill>
-                  <a:srgbClr val="475569"/>
-                </a:solidFill>
-                <a:latin typeface="Calibri"/>
-              </a:rPr>
-              <a:t>• structurer une vraie expérimentation terrain ;</a:t>
-            </a:r>
-          </a:p>
-          <a:p>
-            <a:r>
-              <a:rPr sz="1300">
-                <a:solidFill>
-                  <a:srgbClr val="475569"/>
-                </a:solidFill>
-                <a:latin typeface="Calibri"/>
-              </a:rPr>
-              <a:t>• clarifier le positionnement, les partenaires et les usages prioritaires ;</a:t>
-            </a:r>
-          </a:p>
-          <a:p>
-            <a:r>
-              <a:rPr sz="1300">
-                <a:solidFill>
-                  <a:srgbClr val="475569"/>
-                </a:solidFill>
-                <a:latin typeface="Calibri"/>
-              </a:rPr>
-              <a:t>• consolider le modèle économique ou associatif sans dénaturer le projet bénévole ;</a:t>
-            </a:r>
-          </a:p>
-          <a:p>
-            <a:r>
-              <a:rPr sz="1300">
-                <a:solidFill>
-                  <a:srgbClr val="475569"/>
-                </a:solidFill>
-                <a:latin typeface="Calibri"/>
-              </a:rPr>
-              <a:t>• gagner en méthode, en réseau et en crédibilité auprès des acteurs publics et associatifs.</a:t>
-            </a:r>
-          </a:p>
-          <a:p>
-            <a:r>
-              <a:rPr sz="1300">
-                <a:solidFill>
-                  <a:srgbClr val="475569"/>
-                </a:solidFill>
-                <a:latin typeface="Calibri"/>
-              </a:rPr>
-              <a:t/>
-            </a:r>
-          </a:p>
-          <a:p>
-            <a:r>
-              <a:rPr sz="1300">
-                <a:solidFill>
-                  <a:srgbClr val="475569"/>
-                </a:solidFill>
-                <a:latin typeface="Calibri"/>
-              </a:rPr>
-              <a:t>Conclusion : CleanMyMap est déjà prototypé. Le SNEE/D2E doit aider à transformer ce prototype en projet testé, utile et durable.</a:t>
+            <a:r>
+              <a:rPr sz="1250" b="0" i="0">
+                <a:solidFill>
+                  <a:srgbClr val="475569"/>
+                </a:solidFill>
+                <a:latin typeface="Calibri"/>
+              </a:rPr>
+              <a:t>Le SNEE peut m’aider à avancer avec une posture apprenante :</a:t>
+            </a:r>
+          </a:p>
+          <a:p>
+            <a:r>
+              <a:rPr sz="1250" b="0" i="0">
+                <a:solidFill>
+                  <a:srgbClr val="475569"/>
+                </a:solidFill>
+                <a:latin typeface="Calibri"/>
+              </a:rPr>
+              <a:t>• cadrer une expérimentation terrain sérieuse ;</a:t>
+            </a:r>
+          </a:p>
+          <a:p>
+            <a:r>
+              <a:rPr sz="1250" b="0" i="0">
+                <a:solidFill>
+                  <a:srgbClr val="475569"/>
+                </a:solidFill>
+                <a:latin typeface="Calibri"/>
+              </a:rPr>
+              <a:t>• structurer les retours bénévoles et associations ;</a:t>
+            </a:r>
+          </a:p>
+          <a:p>
+            <a:r>
+              <a:rPr sz="1250" b="0" i="0">
+                <a:solidFill>
+                  <a:srgbClr val="475569"/>
+                </a:solidFill>
+                <a:latin typeface="Calibri"/>
+              </a:rPr>
+              <a:t>• clarifier le cadre associatif, juridique et partenarial ;</a:t>
+            </a:r>
+          </a:p>
+          <a:p>
+            <a:r>
+              <a:rPr sz="1250" b="0" i="0">
+                <a:solidFill>
+                  <a:srgbClr val="475569"/>
+                </a:solidFill>
+                <a:latin typeface="Calibri"/>
+              </a:rPr>
+              <a:t>• bénéficier d’un réseau de mentors et d’acteurs publics ;</a:t>
+            </a:r>
+          </a:p>
+          <a:p>
+            <a:r>
+              <a:rPr sz="1250" b="0" i="0">
+                <a:solidFill>
+                  <a:srgbClr val="475569"/>
+                </a:solidFill>
+                <a:latin typeface="Calibri"/>
+              </a:rPr>
+              <a:t>• apprendre à porter le projet avec méthode.</a:t>
+            </a:r>
+          </a:p>
+          <a:p/>
+          <a:p>
+            <a:r>
+              <a:rPr sz="1250" b="0" i="0">
+                <a:solidFill>
+                  <a:srgbClr val="475569"/>
+                </a:solidFill>
+                <a:latin typeface="Calibri"/>
+              </a:rPr>
+              <a:t>Conclusion : CleanMyMap est déjà prototypé. Pépite doit m’aider à le tester, le cadrer et le rendre utile durablement.</a:t>
             </a:r>
           </a:p>
         </p:txBody>
@@ -5856,7 +6008,7 @@
               </a:rPr>
               <a:t>8</a:t>
             </a:r>
-            <a:endParaRPr lang="en-US" sz="900" dirty="0"/>
+            <a:endParaRPr lang="en-US" sz="900"/>
           </a:p>
         </p:txBody>
       </p:sp>
@@ -5953,7 +6105,7 @@
               <a:buNone/>
             </a:pPr>
             <a:r>
-              <a:rPr lang="en-US" sz="900" dirty="0">
+              <a:rPr lang="en-US" sz="900">
                 <a:solidFill>
                   <a:srgbClr val="475569"/>
                 </a:solidFill>
@@ -5963,7 +6115,7 @@
               </a:rPr>
               <a:t>Pépite Sorbonne Université  ·  SNEE/D2E — Dossier de candidature</a:t>
             </a:r>
-            <a:endParaRPr lang="en-US" sz="900" dirty="0"/>
+            <a:endParaRPr lang="en-US" sz="900"/>
           </a:p>
         </p:txBody>
       </p:sp>

</xml_diff>